<commit_message>
Simplifie le PowerPoint de la SAE (fond blanc, puces, schéma simple)
Co-Authored-By: Claude Opus 5.5 <noreply@anthropic.com>
Claude-Session: https://claude.ai/code/session_01VGmcgWjrz92j7VmNBH7VUY
</commit_message>
<xml_diff>
--- a/sae_iut2030/SAE_IUT2030_boitier_salle.pptx
+++ b/sae_iut2030/SAE_IUT2030_boitier_salle.pptx
@@ -109,17 +109,17 @@
   <p:extLst>
     <p:ext uri="{521415D9-36F7-43E2-AB2F-B90AF26B5E84}">
       <p14:sectionLst xmlns:p14="http://schemas.microsoft.com/office/powerpoint/2010/main">
-        <p14:section name="Titre" id="{c2d88708-82b5-6079-8087-cf02224dc582}">
+        <p14:section name="Titre" id="{1810b617-c6fb-32bc-d090-fd60214793a8}">
           <p14:sldIdLst>
             <p14:sldId id="256"/>
           </p14:sldIdLst>
         </p14:section>
-        <p14:section name="Problématique" id="{c04fc245-04d9-ca83-a55a-361b88c7c701}">
+        <p14:section name="Problématique" id="{0181fd16-9585-84d8-4d1b-52d7ba89369d}">
           <p14:sldIdLst>
             <p14:sldId id="257"/>
           </p14:sldIdLst>
         </p14:section>
-        <p14:section name="Solution" id="{4e532185-22d9-fd68-1c42-5d2bd236bdfe}">
+        <p14:section name="Solution" id="{b80f3828-1833-97b5-527a-c559fff56600}">
           <p14:sldIdLst>
             <p14:sldId id="258"/>
           </p14:sldIdLst>
@@ -528,7 +528,7 @@
           <a:p>
             <a:r>
               <a:rPr lang="en-US" dirty="0"/>
-              <a:t>Présenter le projet en une phrase : un boîtier par salle qui sait qui est là, si la salle est vraiment utilisée, et s'il y a des personnes non autorisées. Deux thématiques couvertes : IoT et Université du futur.</a:t>
+              <a:t>Présenter le projet en une phrase : un boîtier par salle qui sait qui est là, si la salle est vraiment utilisée, et s'il y a des personnes non autorisées.</a:t>
             </a:r>
             <a:endParaRPr lang="en-US" dirty="0"/>
           </a:p>
@@ -616,7 +616,7 @@
           <a:p>
             <a:r>
               <a:rPr lang="en-US" dirty="0"/>
-              <a:t>Trois problèmes concrets, qui ont une cause commune : aucune donnée fiable sur ce qui se passe dans les salles. Insister sur le fait que l'intrusion est une demande de l'équipe pédagogique.</a:t>
+              <a:t>Les trois problèmes ont la même cause : on n'a pas de données fiables sur ce qui se passe dans les salles. La détection d'intrusion répond à une demande de l'équipe pédagogique.</a:t>
             </a:r>
             <a:endParaRPr lang="en-US" dirty="0"/>
           </a:p>
@@ -704,7 +704,7 @@
           <a:p>
             <a:r>
               <a:rPr lang="en-US" dirty="0"/>
-              <a:t>Le cœur du projet est l'émargement (QR dynamique + BLE) ; l'occupation et la détection d'intrusion sont des extensions qui réutilisent le même boîtier. Si le temps manque dans l'année, on a quand même un projet fini. Les données se valident mutuellement : 20 émargés mais salle détectée vide = anomalie. Seul ajout matériel pour l'intrusion : le compteur de passage à la porte ; le reste est du traitement côté serveur. Démonstration prévue : une salle de l'IUT équipée, avec un intrus simulé.</a:t>
+              <a:t>Le cœur du projet est l'émargement ; l'occupation et l'intrusion sont des extensions avec le même boîtier. Les données se vérifient entre elles : 20 émargés mais salle vide = anomalie. Seul matériel en plus pour l'intrusion : le compteur à la porte. Démo prévue : une salle équipée avec un intrus simulé.</a:t>
             </a:r>
             <a:endParaRPr lang="en-US" dirty="0"/>
           </a:p>
@@ -782,7 +782,7 @@
     <p:bg>
       <p:bgPr>
         <a:solidFill>
-          <a:schemeClr val="tx1"/>
+          <a:schemeClr val="bg1"/>
         </a:solidFill>
       </p:bgPr>
     </p:bg>
@@ -805,13 +805,13 @@
           <p:cNvPr id="2" name="Text 0"/>
           <p:cNvSpPr/>
           <p:nvPr>
-            <p:ph idx="100" type="body" hasCustomPrompt="1"/>
-          </p:nvPr>
-        </p:nvSpPr>
-        <p:spPr>
-          <a:xfrm>
-            <a:off x="548640" y="502920"/>
-            <a:ext cx="8046720" cy="320040"/>
+            <p:ph idx="100" type="title" hasCustomPrompt="1"/>
+          </p:nvPr>
+        </p:nvSpPr>
+        <p:spPr>
+          <a:xfrm>
+            <a:off x="685800" y="1371600"/>
+            <a:ext cx="7772400" cy="914400"/>
           </a:xfrm>
           <a:prstGeom prst="rect">
             <a:avLst/>
@@ -822,20 +822,20 @@
         <p:txBody>
           <a:bodyPr wrap="square" rtlCol="0"/>
           <a:lstStyle>
-            <a:lvl1pPr indent="0" marL="0">
+            <a:lvl1pPr algn="ctr" indent="0" marL="0">
               <a:buNone/>
-              <a:defRPr lang="en-US" sz="1300" b="1" spc="300" kern="0" dirty="0">
-                <a:solidFill>
-                  <a:schemeClr val="accent1"/>
+              <a:defRPr lang="en-US" sz="3600" b="1" dirty="0">
+                <a:solidFill>
+                  <a:schemeClr val="tx2"/>
                 </a:solidFill>
               </a:defRPr>
             </a:lvl1pPr>
           </a:lstStyle>
           <a:p>
-            <a:pPr indent="0" marL="0">
+            <a:pPr algn="ctr" indent="0" marL="0">
               <a:buNone/>
             </a:pPr>
-            <a:endParaRPr lang="en-US" sz="1300" dirty="0"/>
+            <a:endParaRPr lang="en-US" sz="3600" dirty="0"/>
           </a:p>
         </p:txBody>
       </p:sp>
@@ -844,13 +844,13 @@
           <p:cNvPr id="3" name="Text 0"/>
           <p:cNvSpPr/>
           <p:nvPr>
-            <p:ph idx="101" type="title" hasCustomPrompt="1"/>
-          </p:nvPr>
-        </p:nvSpPr>
-        <p:spPr>
-          <a:xfrm>
-            <a:off x="548640" y="1234440"/>
-            <a:ext cx="8046720" cy="822960"/>
+            <p:ph idx="101" type="body" hasCustomPrompt="1"/>
+          </p:nvPr>
+        </p:nvSpPr>
+        <p:spPr>
+          <a:xfrm>
+            <a:off x="685800" y="2286000"/>
+            <a:ext cx="7772400" cy="731520"/>
           </a:xfrm>
           <a:prstGeom prst="rect">
             <a:avLst/>
@@ -861,20 +861,20 @@
         <p:txBody>
           <a:bodyPr wrap="square" rtlCol="0"/>
           <a:lstStyle>
-            <a:lvl1pPr algn="l" indent="0" marL="0">
+            <a:lvl1pPr algn="ctr" indent="0" marL="0">
               <a:buNone/>
-              <a:defRPr lang="en-US" sz="4400" b="1" dirty="0">
-                <a:solidFill>
-                  <a:schemeClr val="bg1"/>
+              <a:defRPr lang="en-US" sz="2000" dirty="0">
+                <a:solidFill>
+                  <a:schemeClr val="tx1"/>
                 </a:solidFill>
               </a:defRPr>
             </a:lvl1pPr>
           </a:lstStyle>
           <a:p>
-            <a:pPr algn="l" indent="0" marL="0">
+            <a:pPr algn="ctr" indent="0" marL="0">
               <a:buNone/>
             </a:pPr>
-            <a:endParaRPr lang="en-US" sz="4400" dirty="0"/>
+            <a:endParaRPr lang="en-US" sz="2000" dirty="0"/>
           </a:p>
         </p:txBody>
       </p:sp>
@@ -888,8 +888,8 @@
         </p:nvSpPr>
         <p:spPr>
           <a:xfrm>
-            <a:off x="548640" y="2103120"/>
-            <a:ext cx="8046720" cy="731520"/>
+            <a:off x="685800" y="3657600"/>
+            <a:ext cx="7772400" cy="822960"/>
           </a:xfrm>
           <a:prstGeom prst="rect">
             <a:avLst/>
@@ -900,59 +900,20 @@
         <p:txBody>
           <a:bodyPr wrap="square" rtlCol="0"/>
           <a:lstStyle>
-            <a:lvl1pPr indent="0" marL="0">
+            <a:lvl1pPr algn="ctr" indent="0" marL="0">
               <a:buNone/>
-              <a:defRPr lang="en-US" sz="2000" dirty="0">
-                <a:solidFill>
-                  <a:schemeClr val="accent4"/>
+              <a:defRPr lang="en-US" sz="1600" dirty="0">
+                <a:solidFill>
+                  <a:schemeClr val="tx1"/>
                 </a:solidFill>
               </a:defRPr>
             </a:lvl1pPr>
           </a:lstStyle>
           <a:p>
-            <a:pPr indent="0" marL="0">
+            <a:pPr algn="ctr" indent="0" marL="0">
               <a:buNone/>
             </a:pPr>
-            <a:endParaRPr lang="en-US" sz="2000" dirty="0"/>
-          </a:p>
-        </p:txBody>
-      </p:sp>
-      <p:sp>
-        <p:nvSpPr>
-          <p:cNvPr id="5" name="Text 0"/>
-          <p:cNvSpPr/>
-          <p:nvPr>
-            <p:ph idx="103" type="body" hasCustomPrompt="1"/>
-          </p:nvPr>
-        </p:nvSpPr>
-        <p:spPr>
-          <a:xfrm>
-            <a:off x="4937760" y="3977640"/>
-            <a:ext cx="3657600" cy="640080"/>
-          </a:xfrm>
-          <a:prstGeom prst="rect">
-            <a:avLst/>
-          </a:prstGeom>
-          <a:noFill/>
-          <a:ln/>
-        </p:spPr>
-        <p:txBody>
-          <a:bodyPr wrap="square" rtlCol="0"/>
-          <a:lstStyle>
-            <a:lvl1pPr algn="r" indent="0" marL="0">
-              <a:buNone/>
-              <a:defRPr lang="en-US" sz="1300" dirty="0">
-                <a:solidFill>
-                  <a:schemeClr val="accent4"/>
-                </a:solidFill>
-              </a:defRPr>
-            </a:lvl1pPr>
-          </a:lstStyle>
-          <a:p>
-            <a:pPr algn="r" indent="0" marL="0">
-              <a:buNone/>
-            </a:pPr>
-            <a:endParaRPr lang="en-US" sz="1300" dirty="0"/>
+            <a:endParaRPr lang="en-US" sz="1600" dirty="0"/>
           </a:p>
         </p:txBody>
       </p:sp>
@@ -970,7 +931,7 @@
     <p:bg>
       <p:bgPr>
         <a:solidFill>
-          <a:schemeClr val="bg2"/>
+          <a:schemeClr val="bg1"/>
         </a:solidFill>
       </p:bgPr>
     </p:bg>
@@ -993,13 +954,13 @@
           <p:cNvPr id="2" name="Text 0"/>
           <p:cNvSpPr/>
           <p:nvPr>
-            <p:ph idx="100" type="body" hasCustomPrompt="1"/>
-          </p:nvPr>
-        </p:nvSpPr>
-        <p:spPr>
-          <a:xfrm>
-            <a:off x="457200" y="365760"/>
-            <a:ext cx="8229600" cy="274320"/>
+            <p:ph idx="100" type="title" hasCustomPrompt="1"/>
+          </p:nvPr>
+        </p:nvSpPr>
+        <p:spPr>
+          <a:xfrm>
+            <a:off x="457200" y="320040"/>
+            <a:ext cx="8229600" cy="731520"/>
           </a:xfrm>
           <a:prstGeom prst="rect">
             <a:avLst/>
@@ -1012,9 +973,9 @@
           <a:lstStyle>
             <a:lvl1pPr indent="0" marL="0">
               <a:buNone/>
-              <a:defRPr lang="en-US" sz="1200" b="1" spc="300" kern="0" dirty="0">
-                <a:solidFill>
-                  <a:schemeClr val="accent2"/>
+              <a:defRPr lang="en-US" sz="3000" b="1" dirty="0">
+                <a:solidFill>
+                  <a:schemeClr val="tx2"/>
                 </a:solidFill>
               </a:defRPr>
             </a:lvl1pPr>
@@ -1023,82 +984,7 @@
             <a:pPr indent="0" marL="0">
               <a:buNone/>
             </a:pPr>
-            <a:endParaRPr lang="en-US" sz="1200" dirty="0"/>
-          </a:p>
-        </p:txBody>
-      </p:sp>
-      <p:sp>
-        <p:nvSpPr>
-          <p:cNvPr id="3" name="Text 0"/>
-          <p:cNvSpPr/>
-          <p:nvPr>
-            <p:ph idx="101" type="title" hasCustomPrompt="1"/>
-          </p:nvPr>
-        </p:nvSpPr>
-        <p:spPr>
-          <a:xfrm>
-            <a:off x="457200" y="685800"/>
-            <a:ext cx="8229600" cy="777240"/>
-          </a:xfrm>
-          <a:prstGeom prst="rect">
-            <a:avLst/>
-          </a:prstGeom>
-          <a:noFill/>
-          <a:ln/>
-        </p:spPr>
-        <p:txBody>
-          <a:bodyPr wrap="square" rtlCol="0"/>
-          <a:lstStyle>
-            <a:lvl1pPr algn="l" indent="0" marL="0">
-              <a:buNone/>
-              <a:defRPr lang="en-US" sz="2200" b="1" dirty="0">
-                <a:solidFill>
-                  <a:schemeClr val="tx1"/>
-                </a:solidFill>
-              </a:defRPr>
-            </a:lvl1pPr>
-          </a:lstStyle>
-          <a:p>
-            <a:pPr algn="l" indent="0" marL="0">
-              <a:buNone/>
-            </a:pPr>
-            <a:endParaRPr lang="en-US" sz="2200" dirty="0"/>
-          </a:p>
-        </p:txBody>
-      </p:sp>
-      <p:sp>
-        <p:nvSpPr>
-          <p:cNvPr id="4" name="Text 0"/>
-          <p:cNvSpPr/>
-          <p:nvPr/>
-        </p:nvSpPr>
-        <p:spPr>
-          <a:xfrm>
-            <a:off x="457200" y="4773168"/>
-            <a:ext cx="5486400" cy="228600"/>
-          </a:xfrm>
-          <a:prstGeom prst="rect">
-            <a:avLst/>
-          </a:prstGeom>
-          <a:noFill/>
-          <a:ln/>
-        </p:spPr>
-        <p:txBody>
-          <a:bodyPr wrap="square" lIns="0" tIns="0" rIns="0" bIns="0" rtlCol="0" anchor="ctr"/>
-          <a:lstStyle/>
-          <a:p>
-            <a:pPr indent="0" marL="0">
-              <a:buNone/>
-            </a:pPr>
-            <a:r>
-              <a:rPr lang="en-US" sz="1000" dirty="0">
-                <a:solidFill>
-                  <a:schemeClr val="tx2"/>
-                </a:solidFill>
-              </a:rPr>
-              <a:t>SAE IUT 2030 · Boîtier de salle connecté</a:t>
-            </a:r>
-            <a:endParaRPr lang="en-US" sz="1000" dirty="0"/>
+            <a:endParaRPr lang="en-US" sz="3000" dirty="0"/>
           </a:p>
         </p:txBody>
       </p:sp>
@@ -1114,8 +1000,8 @@
         </p:nvSpPr>
         <p:spPr>
           <a:xfrm>
-            <a:off x="8229600" y="4773168"/>
-            <a:ext cx="457200" cy="228600"/>
+            <a:off x="8229600" y="4754880"/>
+            <a:ext cx="457200" cy="274320"/>
           </a:xfrm>
           <a:prstGeom prst="rect">
             <a:avLst/>
@@ -1127,12 +1013,12 @@
           </a:extLst>
         </p:spPr>
         <p:txBody>
-          <a:bodyPr lIns="0" tIns="0" rIns="0" bIns="0"/>
+          <a:bodyPr/>
           <a:lstStyle>
             <a:lvl1pPr>
-              <a:defRPr sz="1000">
-                <a:solidFill>
-                  <a:schemeClr val="tx2"/>
+              <a:defRPr sz="1100">
+                <a:solidFill>
+                  <a:schemeClr val="tx1"/>
                 </a:solidFill>
               </a:defRPr>
             </a:lvl1pPr>
@@ -1184,8 +1070,8 @@
         </p:nvSpPr>
         <p:spPr>
           <a:xfrm>
-            <a:off x="8229600" y="4773168"/>
-            <a:ext cx="457200" cy="228600"/>
+            <a:off x="8229600" y="4754880"/>
+            <a:ext cx="457200" cy="274320"/>
           </a:xfrm>
           <a:prstGeom prst="rect">
             <a:avLst/>
@@ -1197,12 +1083,12 @@
           </a:extLst>
         </p:spPr>
         <p:txBody>
-          <a:bodyPr lIns="0" tIns="0" rIns="0" bIns="0"/>
+          <a:bodyPr/>
           <a:lstStyle>
             <a:lvl1pPr>
-              <a:defRPr sz="1000">
-                <a:solidFill>
-                  <a:schemeClr val="tx2"/>
+              <a:defRPr sz="1100">
+                <a:solidFill>
+                  <a:schemeClr val="tx1"/>
                 </a:solidFill>
               </a:defRPr>
             </a:lvl1pPr>
@@ -1501,13 +1387,13 @@
           <p:cNvPr id="2" name="Text 0"/>
           <p:cNvSpPr/>
           <p:nvPr>
-            <p:ph idx="100" type="body" hasCustomPrompt="1"/>
-          </p:nvPr>
-        </p:nvSpPr>
-        <p:spPr>
-          <a:xfrm>
-            <a:off x="548640" y="502920"/>
-            <a:ext cx="8046720" cy="320040"/>
+            <p:ph idx="100" type="title" hasCustomPrompt="1"/>
+          </p:nvPr>
+        </p:nvSpPr>
+        <p:spPr>
+          <a:xfrm>
+            <a:off x="685800" y="1371600"/>
+            <a:ext cx="7772400" cy="914400"/>
           </a:xfrm>
           <a:prstGeom prst="rect">
             <a:avLst/>
@@ -1516,21 +1402,21 @@
           <a:ln/>
         </p:spPr>
         <p:txBody>
-          <a:bodyPr wrap="square" lIns="0" tIns="0" rIns="0" bIns="0" rtlCol="0"/>
+          <a:bodyPr wrap="square" rtlCol="0" anchor="ctr"/>
           <a:lstStyle/>
           <a:p>
-            <a:pPr indent="0" marL="0">
+            <a:pPr algn="ctr" indent="0" marL="0">
               <a:buNone/>
             </a:pPr>
             <a:r>
-              <a:rPr lang="en-US" sz="1300" b="1" spc="300" kern="0" dirty="0">
-                <a:solidFill>
-                  <a:schemeClr val="accent1"/>
+              <a:rPr lang="en-US" sz="3600" b="1" dirty="0">
+                <a:solidFill>
+                  <a:schemeClr val="tx2"/>
                 </a:solidFill>
               </a:rPr>
-              <a:t>SAE · IUT 2030 · PARCOURS ESE</a:t>
-            </a:r>
-            <a:endParaRPr lang="en-US" sz="1300" dirty="0"/>
+              <a:t>Boîtier de salle connecté</a:t>
+            </a:r>
+            <a:endParaRPr lang="en-US" sz="3600" dirty="0"/>
           </a:p>
         </p:txBody>
       </p:sp>
@@ -1539,13 +1425,13 @@
           <p:cNvPr id="3" name="Text 0"/>
           <p:cNvSpPr/>
           <p:nvPr>
-            <p:ph idx="101" type="title" hasCustomPrompt="1"/>
-          </p:nvPr>
-        </p:nvSpPr>
-        <p:spPr>
-          <a:xfrm>
-            <a:off x="548640" y="1234440"/>
-            <a:ext cx="8046720" cy="822960"/>
+            <p:ph idx="101" type="body" hasCustomPrompt="1"/>
+          </p:nvPr>
+        </p:nvSpPr>
+        <p:spPr>
+          <a:xfrm>
+            <a:off x="685800" y="2286000"/>
+            <a:ext cx="7772400" cy="731520"/>
           </a:xfrm>
           <a:prstGeom prst="rect">
             <a:avLst/>
@@ -1554,21 +1440,21 @@
           <a:ln/>
         </p:spPr>
         <p:txBody>
-          <a:bodyPr wrap="square" lIns="0" tIns="0" rIns="0" bIns="0" rtlCol="0" anchor="t"/>
+          <a:bodyPr wrap="square" rtlCol="0" anchor="t"/>
           <a:lstStyle/>
           <a:p>
-            <a:pPr algn="l" indent="0" marL="0">
+            <a:pPr algn="ctr" indent="0" marL="0">
               <a:buNone/>
             </a:pPr>
             <a:r>
-              <a:rPr lang="en-US" sz="4400" b="1" dirty="0">
-                <a:solidFill>
-                  <a:schemeClr val="bg1"/>
+              <a:rPr lang="en-US" sz="2000" dirty="0">
+                <a:solidFill>
+                  <a:schemeClr val="tx1"/>
                 </a:solidFill>
               </a:rPr>
-              <a:t>Boîtier de salle connecté</a:t>
-            </a:r>
-            <a:endParaRPr lang="en-US" sz="4400" dirty="0"/>
+              <a:t>Émargement, occupation des salles et détection d'intrusion</a:t>
+            </a:r>
+            <a:endParaRPr lang="en-US" sz="2000" dirty="0"/>
           </a:p>
         </p:txBody>
       </p:sp>
@@ -1582,8 +1468,8 @@
         </p:nvSpPr>
         <p:spPr>
           <a:xfrm>
-            <a:off x="548640" y="2103120"/>
-            <a:ext cx="8046720" cy="731520"/>
+            <a:off x="685800" y="3657600"/>
+            <a:ext cx="7772400" cy="822960"/>
           </a:xfrm>
           <a:prstGeom prst="rect">
             <a:avLst/>
@@ -1592,191 +1478,35 @@
           <a:ln/>
         </p:spPr>
         <p:txBody>
-          <a:bodyPr wrap="square" lIns="0" tIns="0" rIns="0" bIns="0" rtlCol="0" anchor="t"/>
-          <a:lstStyle/>
-          <a:p>
-            <a:pPr indent="0" marL="0">
-              <a:buNone/>
-            </a:pPr>
-            <a:r>
-              <a:rPr lang="en-US" sz="2000" dirty="0">
-                <a:solidFill>
-                  <a:schemeClr val="accent4"/>
-                </a:solidFill>
-              </a:rPr>
-              <a:t>Émargement sécurisé, occupation des salles et détection d'intrusion</a:t>
-            </a:r>
-            <a:endParaRPr lang="en-US" sz="2000" dirty="0"/>
-          </a:p>
-        </p:txBody>
-      </p:sp>
-      <p:sp>
-        <p:nvSpPr>
-          <p:cNvPr id="5" name="Text 0"/>
-          <p:cNvSpPr/>
-          <p:nvPr>
-            <p:ph idx="103" type="body" hasCustomPrompt="1"/>
-          </p:nvPr>
-        </p:nvSpPr>
-        <p:spPr>
-          <a:xfrm>
-            <a:off x="4937760" y="3977640"/>
-            <a:ext cx="3657600" cy="640080"/>
-          </a:xfrm>
-          <a:prstGeom prst="rect">
-            <a:avLst/>
-          </a:prstGeom>
-          <a:noFill/>
-          <a:ln/>
-        </p:spPr>
-        <p:txBody>
-          <a:bodyPr wrap="square" lIns="0" tIns="0" rIns="0" bIns="0" rtlCol="0" anchor="b"/>
-          <a:lstStyle/>
-          <a:p>
-            <a:pPr algn="r" indent="0" marL="0">
-              <a:buNone/>
-            </a:pPr>
-            <a:r>
-              <a:rPr lang="en-US" sz="1300" dirty="0">
-                <a:solidFill>
-                  <a:schemeClr val="accent4"/>
-                </a:solidFill>
-              </a:rPr>
-              <a:t>Équipe : [Nom Prénom]</a:t>
-            </a:r>
-            <a:endParaRPr lang="en-US" sz="1300" dirty="0"/>
-          </a:p>
-          <a:p>
-            <a:pPr algn="r" indent="0" marL="0">
-              <a:buNone/>
-            </a:pPr>
-            <a:r>
-              <a:rPr lang="en-US" sz="1300" dirty="0">
-                <a:solidFill>
-                  <a:schemeClr val="accent4"/>
-                </a:solidFill>
-              </a:rPr>
-              <a:t>[Nom Prénom] · [Nom Prénom]</a:t>
-            </a:r>
-            <a:endParaRPr lang="en-US" sz="1300" dirty="0"/>
-          </a:p>
-        </p:txBody>
-      </p:sp>
-      <p:sp>
-        <p:nvSpPr>
-          <p:cNvPr id="6" name="Pastille IoT"/>
-          <p:cNvSpPr/>
-          <p:nvPr/>
-        </p:nvSpPr>
-        <p:spPr>
-          <a:xfrm>
-            <a:off x="548640" y="4206240"/>
-            <a:ext cx="2377440" cy="411480"/>
-          </a:xfrm>
-          <a:prstGeom prst="roundRect">
-            <a:avLst>
-              <a:gd name="adj" fmla="val 48889"/>
-            </a:avLst>
-          </a:prstGeom>
-          <a:solidFill>
-            <a:schemeClr val="accent1"/>
-          </a:solidFill>
-          <a:ln/>
-        </p:spPr>
-      </p:sp>
-      <p:sp>
-        <p:nvSpPr>
-          <p:cNvPr id="7" name="Text 5"/>
-          <p:cNvSpPr txBox="1"/>
-          <p:nvPr/>
-        </p:nvSpPr>
-        <p:spPr>
-          <a:xfrm>
-            <a:off x="548640" y="4206240"/>
-            <a:ext cx="2377440" cy="411480"/>
-          </a:xfrm>
-          <a:prstGeom prst="rect">
-            <a:avLst/>
-          </a:prstGeom>
-          <a:noFill/>
-          <a:ln/>
-        </p:spPr>
-        <p:txBody>
-          <a:bodyPr wrap="square" lIns="0" tIns="0" rIns="0" bIns="0" rtlCol="0" anchor="ctr"/>
+          <a:bodyPr wrap="square" rtlCol="0" anchor="t"/>
           <a:lstStyle/>
           <a:p>
             <a:pPr algn="ctr" indent="0" marL="0">
               <a:buNone/>
             </a:pPr>
             <a:r>
-              <a:rPr lang="en-US" sz="1300" b="1" dirty="0">
+              <a:rPr lang="en-US" sz="1600" dirty="0">
                 <a:solidFill>
                   <a:schemeClr val="tx1"/>
                 </a:solidFill>
               </a:rPr>
-              <a:t>Objets connectés (IoT)</a:t>
-            </a:r>
-            <a:endParaRPr lang="en-US" sz="1300" dirty="0"/>
-          </a:p>
-        </p:txBody>
-      </p:sp>
-      <p:sp>
-        <p:nvSpPr>
-          <p:cNvPr id="8" name="Pastille Université"/>
-          <p:cNvSpPr/>
-          <p:nvPr/>
-        </p:nvSpPr>
-        <p:spPr>
-          <a:xfrm>
-            <a:off x="3063240" y="4206240"/>
-            <a:ext cx="2194560" cy="411480"/>
-          </a:xfrm>
-          <a:prstGeom prst="roundRect">
-            <a:avLst>
-              <a:gd name="adj" fmla="val 48889"/>
-            </a:avLst>
-          </a:prstGeom>
-          <a:ln w="19050">
-            <a:solidFill>
-              <a:schemeClr val="accent1"/>
-            </a:solidFill>
-            <a:prstDash val="solid"/>
-          </a:ln>
-        </p:spPr>
-      </p:sp>
-      <p:sp>
-        <p:nvSpPr>
-          <p:cNvPr id="9" name="Text 7"/>
-          <p:cNvSpPr txBox="1"/>
-          <p:nvPr/>
-        </p:nvSpPr>
-        <p:spPr>
-          <a:xfrm>
-            <a:off x="3063240" y="4206240"/>
-            <a:ext cx="2194560" cy="411480"/>
-          </a:xfrm>
-          <a:prstGeom prst="rect">
-            <a:avLst/>
-          </a:prstGeom>
-          <a:noFill/>
-          <a:ln/>
-        </p:spPr>
-        <p:txBody>
-          <a:bodyPr wrap="square" lIns="0" tIns="0" rIns="0" bIns="0" rtlCol="0" anchor="ctr"/>
-          <a:lstStyle/>
+              <a:t>SAE – IUT 2030 – Thèmes : IoT et Université du futur</a:t>
+            </a:r>
+            <a:endParaRPr lang="en-US" sz="1600" dirty="0"/>
+          </a:p>
           <a:p>
             <a:pPr algn="ctr" indent="0" marL="0">
               <a:buNone/>
             </a:pPr>
             <a:r>
-              <a:rPr lang="en-US" sz="1300" b="1" dirty="0">
-                <a:solidFill>
-                  <a:schemeClr val="bg1"/>
+              <a:rPr lang="en-US" sz="1600" dirty="0">
+                <a:solidFill>
+                  <a:schemeClr val="tx1"/>
                 </a:solidFill>
               </a:rPr>
-              <a:t>Université du futur</a:t>
-            </a:r>
-            <a:endParaRPr lang="en-US" sz="1300" dirty="0"/>
+              <a:t>[Nom Prénom], [Nom Prénom], [Nom Prénom]</a:t>
+            </a:r>
+            <a:endParaRPr lang="en-US" sz="1600" dirty="0"/>
           </a:p>
         </p:txBody>
       </p:sp>
@@ -1810,13 +1540,13 @@
           <p:cNvPr id="2" name="Text 0"/>
           <p:cNvSpPr/>
           <p:nvPr>
-            <p:ph idx="100" type="body" hasCustomPrompt="1"/>
-          </p:nvPr>
-        </p:nvSpPr>
-        <p:spPr>
-          <a:xfrm>
-            <a:off x="457200" y="365760"/>
-            <a:ext cx="8229600" cy="274320"/>
+            <p:ph idx="100" type="title" hasCustomPrompt="1"/>
+          </p:nvPr>
+        </p:nvSpPr>
+        <p:spPr>
+          <a:xfrm>
+            <a:off x="457200" y="320040"/>
+            <a:ext cx="8229600" cy="731520"/>
           </a:xfrm>
           <a:prstGeom prst="rect">
             <a:avLst/>
@@ -1825,36 +1555,34 @@
           <a:ln/>
         </p:spPr>
         <p:txBody>
-          <a:bodyPr wrap="square" lIns="0" tIns="0" rIns="0" bIns="0" rtlCol="0"/>
+          <a:bodyPr wrap="square" rtlCol="0" anchor="ctr"/>
           <a:lstStyle/>
           <a:p>
             <a:pPr indent="0" marL="0">
               <a:buNone/>
             </a:pPr>
             <a:r>
-              <a:rPr lang="en-US" sz="1200" b="1" spc="300" kern="0" dirty="0">
-                <a:solidFill>
-                  <a:schemeClr val="accent2"/>
+              <a:rPr lang="en-US" sz="3000" b="1" dirty="0">
+                <a:solidFill>
+                  <a:schemeClr val="tx2"/>
                 </a:solidFill>
               </a:rPr>
-              <a:t>LA PROBLÉMATIQUE</a:t>
-            </a:r>
-            <a:endParaRPr lang="en-US" sz="1200" dirty="0"/>
-          </a:p>
-        </p:txBody>
-      </p:sp>
-      <p:sp>
-        <p:nvSpPr>
-          <p:cNvPr id="3" name="Text 0"/>
-          <p:cNvSpPr/>
-          <p:nvPr>
-            <p:ph idx="101" type="title" hasCustomPrompt="1"/>
-          </p:nvPr>
-        </p:nvSpPr>
-        <p:spPr>
-          <a:xfrm>
-            <a:off x="457200" y="685800"/>
-            <a:ext cx="8229600" cy="777240"/>
+              <a:t>Problématique</a:t>
+            </a:r>
+            <a:endParaRPr lang="en-US" sz="3000" dirty="0"/>
+          </a:p>
+        </p:txBody>
+      </p:sp>
+      <p:sp>
+        <p:nvSpPr>
+          <p:cNvPr id="3" name="Text 1"/>
+          <p:cNvSpPr txBox="1"/>
+          <p:nvPr/>
+        </p:nvSpPr>
+        <p:spPr>
+          <a:xfrm>
+            <a:off x="457200" y="1188720"/>
+            <a:ext cx="8229600" cy="731520"/>
           </a:xfrm>
           <a:prstGeom prst="rect">
             <a:avLst/>
@@ -1863,107 +1591,34 @@
           <a:ln/>
         </p:spPr>
         <p:txBody>
-          <a:bodyPr wrap="square" lIns="0" tIns="0" rIns="0" bIns="0" rtlCol="0" anchor="t"/>
+          <a:bodyPr wrap="square" rtlCol="0" anchor="t"/>
           <a:lstStyle/>
           <a:p>
-            <a:pPr algn="l" indent="0" marL="0">
+            <a:pPr indent="0" marL="0">
               <a:buNone/>
             </a:pPr>
             <a:r>
-              <a:rPr lang="en-US" sz="2200" b="1" dirty="0">
+              <a:rPr lang="en-US" sz="1800" i="1" dirty="0">
                 <a:solidFill>
                   <a:schemeClr val="tx1"/>
                 </a:solidFill>
               </a:rPr>
-              <a:t>L'IUT ne sait pas en temps réel qui est présent, quelles salles sont vraiment utilisées, ni si des personnes non autorisées s'y trouvent.</a:t>
-            </a:r>
-            <a:endParaRPr lang="en-US" sz="2200" dirty="0"/>
-          </a:p>
-        </p:txBody>
-      </p:sp>
-      <p:sp>
-        <p:nvSpPr>
-          <p:cNvPr id="4" name="Carte Émargement"/>
-          <p:cNvSpPr/>
-          <p:nvPr/>
-        </p:nvSpPr>
-        <p:spPr>
-          <a:xfrm>
-            <a:off x="457200" y="1920240"/>
-            <a:ext cx="2560320" cy="2606040"/>
-          </a:xfrm>
-          <a:prstGeom prst="roundRect">
-            <a:avLst>
-              <a:gd name="adj" fmla="val 3571"/>
-            </a:avLst>
-          </a:prstGeom>
-          <a:solidFill>
-            <a:schemeClr val="bg1"/>
-          </a:solidFill>
-          <a:ln/>
-          <a:effectLst>
-            <a:outerShdw sx="100000" sy="100000" kx="0" ky="0" algn="bl" rotWithShape="0" blurRad="76200" dist="25400" dir="5400000">
-              <a:srgbClr val="13223A">
-                <a:alpha val="12000"/>
-              </a:srgbClr>
-            </a:outerShdw>
-          </a:effectLst>
-        </p:spPr>
-      </p:sp>
-      <p:sp>
-        <p:nvSpPr>
-          <p:cNvPr id="5" name="Cercle Émargement"/>
-          <p:cNvSpPr/>
-          <p:nvPr/>
-        </p:nvSpPr>
-        <p:spPr>
-          <a:xfrm>
-            <a:off x="685800" y="2148840"/>
-            <a:ext cx="548640" cy="548640"/>
-          </a:xfrm>
-          <a:prstGeom prst="ellipse">
-            <a:avLst/>
-          </a:prstGeom>
-          <a:solidFill>
-            <a:schemeClr val="tx1"/>
-          </a:solidFill>
-          <a:ln/>
-        </p:spPr>
-      </p:sp>
-      <p:pic>
-        <p:nvPicPr>
-          <p:cNvPr id="6" name="Image 0" descr="Émargement">    </p:cNvPr>
-          <p:cNvPicPr>
-            <a:picLocks noChangeAspect="1"/>
-          </p:cNvPicPr>
-          <p:nvPr/>
-        </p:nvPicPr>
-        <p:blipFill>
-          <a:blip r:embed="rId1"/>
-          <a:stretch>
-            <a:fillRect/>
-          </a:stretch>
-        </p:blipFill>
-        <p:spPr>
-          <a:xfrm>
-            <a:off x="822960" y="2286000"/>
-            <a:ext cx="274320" cy="274320"/>
-          </a:xfrm>
-          <a:prstGeom prst="rect">
-            <a:avLst/>
-          </a:prstGeom>
-        </p:spPr>
-      </p:pic>
-      <p:sp>
-        <p:nvSpPr>
-          <p:cNvPr id="7" name="Text 4"/>
+              <a:t>Comment savoir en temps réel qui est présent dans une salle, si elle est vraiment utilisée et si des personnes non autorisées s'y trouvent ?</a:t>
+            </a:r>
+            <a:endParaRPr lang="en-US" sz="1800" dirty="0"/>
+          </a:p>
+        </p:txBody>
+      </p:sp>
+      <p:sp>
+        <p:nvSpPr>
+          <p:cNvPr id="4" name="Text 2"/>
           <p:cNvSpPr txBox="1"/>
           <p:nvPr/>
         </p:nvSpPr>
         <p:spPr>
           <a:xfrm>
-            <a:off x="1371600" y="2148840"/>
-            <a:ext cx="1508760" cy="548640"/>
+            <a:off x="457200" y="2057400"/>
+            <a:ext cx="8229600" cy="2377440"/>
           </a:xfrm>
           <a:prstGeom prst="rect">
             <a:avLst/>
@@ -1972,476 +1627,79 @@
           <a:ln/>
         </p:spPr>
         <p:txBody>
-          <a:bodyPr wrap="square" lIns="0" tIns="0" rIns="0" bIns="0" rtlCol="0" anchor="ctr"/>
-          <a:lstStyle/>
-          <a:p>
-            <a:pPr indent="0" marL="0">
-              <a:buNone/>
-            </a:pPr>
-            <a:r>
-              <a:rPr lang="en-US" sz="1800" b="1" dirty="0">
-                <a:solidFill>
-                  <a:schemeClr val="tx1"/>
-                </a:solidFill>
-                <a:latin typeface="+mj-lt" pitchFamily="34" charset="0"/>
-                <a:ea typeface="+mj-lt" pitchFamily="34" charset="-122"/>
-                <a:cs typeface="+mj-lt" pitchFamily="34" charset="-120"/>
-              </a:rPr>
-              <a:t>Émargement</a:t>
-            </a:r>
-            <a:endParaRPr lang="en-US" sz="1800" dirty="0"/>
-          </a:p>
-        </p:txBody>
-      </p:sp>
-      <p:sp>
-        <p:nvSpPr>
-          <p:cNvPr id="8" name="Text 5"/>
-          <p:cNvSpPr txBox="1"/>
-          <p:nvPr/>
-        </p:nvSpPr>
-        <p:spPr>
-          <a:xfrm>
-            <a:off x="685800" y="2926080"/>
-            <a:ext cx="2148840" cy="1645920"/>
-          </a:xfrm>
-          <a:prstGeom prst="rect">
-            <a:avLst/>
-          </a:prstGeom>
-          <a:noFill/>
-          <a:ln/>
-        </p:spPr>
-        <p:txBody>
-          <a:bodyPr wrap="square" lIns="0" tIns="0" rIns="0" bIns="0" rtlCol="0" anchor="t"/>
+          <a:bodyPr wrap="square" rtlCol="0" anchor="t"/>
           <a:lstStyle/>
           <a:p>
             <a:pPr marL="342900" indent="-342900">
               <a:spcAft>
-                <a:spcPts val="400"/>
+                <a:spcPts val="1000"/>
               </a:spcAft>
               <a:buSzPct val="100000"/>
               <a:buChar char="•"/>
             </a:pPr>
             <a:r>
-              <a:rPr lang="en-US" sz="1300" dirty="0">
-                <a:solidFill>
-                  <a:schemeClr val="tx2"/>
+              <a:rPr lang="en-US" sz="1800" dirty="0">
+                <a:solidFill>
+                  <a:schemeClr val="tx1"/>
                 </a:solidFill>
               </a:rPr>
-              <a:t>Feuille papier lente à faire circuler</a:t>
-            </a:r>
-            <a:endParaRPr lang="en-US" sz="1300" dirty="0"/>
+              <a:t>L'émargement papier est lent et on peut signer pour un absent</a:t>
+            </a:r>
+            <a:endParaRPr lang="en-US" sz="1800" dirty="0"/>
           </a:p>
           <a:p>
             <a:pPr marL="342900" indent="-342900">
               <a:spcAft>
-                <a:spcPts val="400"/>
+                <a:spcPts val="1000"/>
               </a:spcAft>
               <a:buSzPct val="100000"/>
               <a:buChar char="•"/>
             </a:pPr>
             <a:r>
-              <a:rPr lang="en-US" sz="1300" dirty="0">
-                <a:solidFill>
-                  <a:schemeClr val="tx2"/>
+              <a:rPr lang="en-US" sz="1800" dirty="0">
+                <a:solidFill>
+                  <a:schemeClr val="tx1"/>
                 </a:solidFill>
               </a:rPr>
-              <a:t>Falsifiable : on signe pour un absent</a:t>
-            </a:r>
-            <a:endParaRPr lang="en-US" sz="1300" dirty="0"/>
+              <a:t>Des salles sont réservées mais vides, et on ne trouve pas les salles libres</a:t>
+            </a:r>
+            <a:endParaRPr lang="en-US" sz="1800" dirty="0"/>
           </a:p>
           <a:p>
             <a:pPr marL="342900" indent="-342900">
               <a:spcAft>
-                <a:spcPts val="400"/>
+                <a:spcPts val="1000"/>
               </a:spcAft>
               <a:buSzPct val="100000"/>
               <a:buChar char="•"/>
             </a:pPr>
             <a:r>
-              <a:rPr lang="en-US" sz="1300" dirty="0">
-                <a:solidFill>
-                  <a:schemeClr val="tx2"/>
+              <a:rPr lang="en-US" sz="1800" dirty="0">
+                <a:solidFill>
+                  <a:schemeClr val="tx1"/>
                 </a:solidFill>
               </a:rPr>
-              <a:t>Saisie manuelle après le cours</a:t>
-            </a:r>
-            <a:endParaRPr lang="en-US" sz="1300" dirty="0"/>
-          </a:p>
-        </p:txBody>
-      </p:sp>
-      <p:sp>
-        <p:nvSpPr>
-          <p:cNvPr id="9" name="Carte Occupation"/>
-          <p:cNvSpPr/>
-          <p:nvPr/>
-        </p:nvSpPr>
-        <p:spPr>
-          <a:xfrm>
-            <a:off x="3291840" y="1920240"/>
-            <a:ext cx="2560320" cy="2606040"/>
-          </a:xfrm>
-          <a:prstGeom prst="roundRect">
-            <a:avLst>
-              <a:gd name="adj" fmla="val 3571"/>
-            </a:avLst>
-          </a:prstGeom>
-          <a:solidFill>
-            <a:schemeClr val="bg1"/>
-          </a:solidFill>
-          <a:ln/>
-          <a:effectLst>
-            <a:outerShdw sx="100000" sy="100000" kx="0" ky="0" algn="bl" rotWithShape="0" blurRad="76200" dist="25400" dir="5400000">
-              <a:srgbClr val="13223A">
-                <a:alpha val="12000"/>
-              </a:srgbClr>
-            </a:outerShdw>
-          </a:effectLst>
-        </p:spPr>
-      </p:sp>
-      <p:sp>
-        <p:nvSpPr>
-          <p:cNvPr id="10" name="Cercle Occupation"/>
-          <p:cNvSpPr/>
-          <p:nvPr/>
-        </p:nvSpPr>
-        <p:spPr>
-          <a:xfrm>
-            <a:off x="3520440" y="2148840"/>
-            <a:ext cx="548640" cy="548640"/>
-          </a:xfrm>
-          <a:prstGeom prst="ellipse">
-            <a:avLst/>
-          </a:prstGeom>
-          <a:solidFill>
-            <a:schemeClr val="tx1"/>
-          </a:solidFill>
-          <a:ln/>
-        </p:spPr>
-      </p:sp>
-      <p:pic>
-        <p:nvPicPr>
-          <p:cNvPr id="11" name="Image 1" descr="Occupation">    </p:cNvPr>
-          <p:cNvPicPr>
-            <a:picLocks noChangeAspect="1"/>
-          </p:cNvPicPr>
-          <p:nvPr/>
-        </p:nvPicPr>
-        <p:blipFill>
-          <a:blip r:embed="rId2"/>
-          <a:stretch>
-            <a:fillRect/>
-          </a:stretch>
-        </p:blipFill>
-        <p:spPr>
-          <a:xfrm>
-            <a:off x="3657600" y="2286000"/>
-            <a:ext cx="274320" cy="274320"/>
-          </a:xfrm>
-          <a:prstGeom prst="rect">
-            <a:avLst/>
-          </a:prstGeom>
-        </p:spPr>
-      </p:pic>
-      <p:sp>
-        <p:nvSpPr>
-          <p:cNvPr id="12" name="Text 8"/>
-          <p:cNvSpPr txBox="1"/>
-          <p:nvPr/>
-        </p:nvSpPr>
-        <p:spPr>
-          <a:xfrm>
-            <a:off x="4206240" y="2148840"/>
-            <a:ext cx="1508760" cy="548640"/>
-          </a:xfrm>
-          <a:prstGeom prst="rect">
-            <a:avLst/>
-          </a:prstGeom>
-          <a:noFill/>
-          <a:ln/>
-        </p:spPr>
-        <p:txBody>
-          <a:bodyPr wrap="square" lIns="0" tIns="0" rIns="0" bIns="0" rtlCol="0" anchor="ctr"/>
-          <a:lstStyle/>
-          <a:p>
-            <a:pPr indent="0" marL="0">
-              <a:buNone/>
-            </a:pPr>
-            <a:r>
-              <a:rPr lang="en-US" sz="1800" b="1" dirty="0">
-                <a:solidFill>
-                  <a:schemeClr val="tx1"/>
-                </a:solidFill>
-                <a:latin typeface="+mj-lt" pitchFamily="34" charset="0"/>
-                <a:ea typeface="+mj-lt" pitchFamily="34" charset="-122"/>
-                <a:cs typeface="+mj-lt" pitchFamily="34" charset="-120"/>
-              </a:rPr>
-              <a:t>Occupation</a:t>
+              <a:t>Chauffage et lumière restent allumés dans des salles vides</a:t>
             </a:r>
             <a:endParaRPr lang="en-US" sz="1800" dirty="0"/>
           </a:p>
-        </p:txBody>
-      </p:sp>
-      <p:sp>
-        <p:nvSpPr>
-          <p:cNvPr id="13" name="Text 9"/>
-          <p:cNvSpPr txBox="1"/>
-          <p:nvPr/>
-        </p:nvSpPr>
-        <p:spPr>
-          <a:xfrm>
-            <a:off x="3520440" y="2926080"/>
-            <a:ext cx="2148840" cy="1645920"/>
-          </a:xfrm>
-          <a:prstGeom prst="rect">
-            <a:avLst/>
-          </a:prstGeom>
-          <a:noFill/>
-          <a:ln/>
-        </p:spPr>
-        <p:txBody>
-          <a:bodyPr wrap="square" lIns="0" tIns="0" rIns="0" bIns="0" rtlCol="0" anchor="t"/>
-          <a:lstStyle/>
           <a:p>
             <a:pPr marL="342900" indent="-342900">
               <a:spcAft>
-                <a:spcPts val="400"/>
+                <a:spcPts val="1000"/>
               </a:spcAft>
               <a:buSzPct val="100000"/>
               <a:buChar char="•"/>
             </a:pPr>
             <a:r>
-              <a:rPr lang="en-US" sz="1300" dirty="0">
-                <a:solidFill>
-                  <a:schemeClr val="tx2"/>
+              <a:rPr lang="en-US" sz="1800" dirty="0">
+                <a:solidFill>
+                  <a:schemeClr val="tx1"/>
                 </a:solidFill>
               </a:rPr>
-              <a:t>Salles réservées mais vides</a:t>
-            </a:r>
-            <a:endParaRPr lang="en-US" sz="1300" dirty="0"/>
-          </a:p>
-          <a:p>
-            <a:pPr marL="342900" indent="-342900">
-              <a:spcAft>
-                <a:spcPts val="400"/>
-              </a:spcAft>
-              <a:buSzPct val="100000"/>
-              <a:buChar char="•"/>
-            </a:pPr>
-            <a:r>
-              <a:rPr lang="en-US" sz="1300" dirty="0">
-                <a:solidFill>
-                  <a:schemeClr val="tx2"/>
-                </a:solidFill>
-              </a:rPr>
-              <a:t>Salles libres introuvables</a:t>
-            </a:r>
-            <a:endParaRPr lang="en-US" sz="1300" dirty="0"/>
-          </a:p>
-          <a:p>
-            <a:pPr marL="342900" indent="-342900">
-              <a:spcAft>
-                <a:spcPts val="400"/>
-              </a:spcAft>
-              <a:buSzPct val="100000"/>
-              <a:buChar char="•"/>
-            </a:pPr>
-            <a:r>
-              <a:rPr lang="en-US" sz="1300" dirty="0">
-                <a:solidFill>
-                  <a:schemeClr val="tx2"/>
-                </a:solidFill>
-              </a:rPr>
-              <a:t>Chauffage et éclairage inutiles, air mal renouvelé</a:t>
-            </a:r>
-            <a:endParaRPr lang="en-US" sz="1300" dirty="0"/>
-          </a:p>
-        </p:txBody>
-      </p:sp>
-      <p:sp>
-        <p:nvSpPr>
-          <p:cNvPr id="14" name="Carte Intrusion"/>
-          <p:cNvSpPr/>
-          <p:nvPr/>
-        </p:nvSpPr>
-        <p:spPr>
-          <a:xfrm>
-            <a:off x="6126480" y="1920240"/>
-            <a:ext cx="2560320" cy="2606040"/>
-          </a:xfrm>
-          <a:prstGeom prst="roundRect">
-            <a:avLst>
-              <a:gd name="adj" fmla="val 3571"/>
-            </a:avLst>
-          </a:prstGeom>
-          <a:solidFill>
-            <a:schemeClr val="bg1"/>
-          </a:solidFill>
-          <a:ln/>
-          <a:effectLst>
-            <a:outerShdw sx="100000" sy="100000" kx="0" ky="0" algn="bl" rotWithShape="0" blurRad="76200" dist="25400" dir="5400000">
-              <a:srgbClr val="13223A">
-                <a:alpha val="12000"/>
-              </a:srgbClr>
-            </a:outerShdw>
-          </a:effectLst>
-        </p:spPr>
-      </p:sp>
-      <p:sp>
-        <p:nvSpPr>
-          <p:cNvPr id="15" name="Cercle Intrusion"/>
-          <p:cNvSpPr/>
-          <p:nvPr/>
-        </p:nvSpPr>
-        <p:spPr>
-          <a:xfrm>
-            <a:off x="6355080" y="2148840"/>
-            <a:ext cx="548640" cy="548640"/>
-          </a:xfrm>
-          <a:prstGeom prst="ellipse">
-            <a:avLst/>
-          </a:prstGeom>
-          <a:solidFill>
-            <a:schemeClr val="accent1"/>
-          </a:solidFill>
-          <a:ln/>
-        </p:spPr>
-      </p:sp>
-      <p:pic>
-        <p:nvPicPr>
-          <p:cNvPr id="16" name="Image 2" descr="Intrusion">    </p:cNvPr>
-          <p:cNvPicPr>
-            <a:picLocks noChangeAspect="1"/>
-          </p:cNvPicPr>
-          <p:nvPr/>
-        </p:nvPicPr>
-        <p:blipFill>
-          <a:blip r:embed="rId3"/>
-          <a:stretch>
-            <a:fillRect/>
-          </a:stretch>
-        </p:blipFill>
-        <p:spPr>
-          <a:xfrm>
-            <a:off x="6492240" y="2286000"/>
-            <a:ext cx="274320" cy="274320"/>
-          </a:xfrm>
-          <a:prstGeom prst="rect">
-            <a:avLst/>
-          </a:prstGeom>
-        </p:spPr>
-      </p:pic>
-      <p:sp>
-        <p:nvSpPr>
-          <p:cNvPr id="17" name="Text 12"/>
-          <p:cNvSpPr txBox="1"/>
-          <p:nvPr/>
-        </p:nvSpPr>
-        <p:spPr>
-          <a:xfrm>
-            <a:off x="7040880" y="2148840"/>
-            <a:ext cx="1508760" cy="548640"/>
-          </a:xfrm>
-          <a:prstGeom prst="rect">
-            <a:avLst/>
-          </a:prstGeom>
-          <a:noFill/>
-          <a:ln/>
-        </p:spPr>
-        <p:txBody>
-          <a:bodyPr wrap="square" lIns="0" tIns="0" rIns="0" bIns="0" rtlCol="0" anchor="ctr"/>
-          <a:lstStyle/>
-          <a:p>
-            <a:pPr indent="0" marL="0">
-              <a:buNone/>
-            </a:pPr>
-            <a:r>
-              <a:rPr lang="en-US" sz="1800" b="1" dirty="0">
-                <a:solidFill>
-                  <a:schemeClr val="tx1"/>
-                </a:solidFill>
-                <a:latin typeface="+mj-lt" pitchFamily="34" charset="0"/>
-                <a:ea typeface="+mj-lt" pitchFamily="34" charset="-122"/>
-                <a:cs typeface="+mj-lt" pitchFamily="34" charset="-120"/>
-              </a:rPr>
-              <a:t>Intrusion</a:t>
+              <a:t>Des personnes peuvent utiliser une salle hors cours ou s'incruster sans être inscrites</a:t>
             </a:r>
             <a:endParaRPr lang="en-US" sz="1800" dirty="0"/>
-          </a:p>
-        </p:txBody>
-      </p:sp>
-      <p:sp>
-        <p:nvSpPr>
-          <p:cNvPr id="18" name="Text 13"/>
-          <p:cNvSpPr txBox="1"/>
-          <p:nvPr/>
-        </p:nvSpPr>
-        <p:spPr>
-          <a:xfrm>
-            <a:off x="6355080" y="2926080"/>
-            <a:ext cx="2148840" cy="1645920"/>
-          </a:xfrm>
-          <a:prstGeom prst="rect">
-            <a:avLst/>
-          </a:prstGeom>
-          <a:noFill/>
-          <a:ln/>
-        </p:spPr>
-        <p:txBody>
-          <a:bodyPr wrap="square" lIns="0" tIns="0" rIns="0" bIns="0" rtlCol="0" anchor="t"/>
-          <a:lstStyle/>
-          <a:p>
-            <a:pPr marL="342900" indent="-342900">
-              <a:spcAft>
-                <a:spcPts val="400"/>
-              </a:spcAft>
-              <a:buSzPct val="100000"/>
-              <a:buChar char="•"/>
-            </a:pPr>
-            <a:r>
-              <a:rPr lang="en-US" sz="1300" dirty="0">
-                <a:solidFill>
-                  <a:schemeClr val="tx2"/>
-                </a:solidFill>
-              </a:rPr>
-              <a:t>Salle utilisée hors créneau</a:t>
-            </a:r>
-            <a:endParaRPr lang="en-US" sz="1300" dirty="0"/>
-          </a:p>
-          <a:p>
-            <a:pPr marL="342900" indent="-342900">
-              <a:spcAft>
-                <a:spcPts val="400"/>
-              </a:spcAft>
-              <a:buSzPct val="100000"/>
-              <a:buChar char="•"/>
-            </a:pPr>
-            <a:r>
-              <a:rPr lang="en-US" sz="1300" dirty="0">
-                <a:solidFill>
-                  <a:schemeClr val="tx2"/>
-                </a:solidFill>
-              </a:rPr>
-              <a:t>Personnes non inscrites au cours</a:t>
-            </a:r>
-            <a:endParaRPr lang="en-US" sz="1300" dirty="0"/>
-          </a:p>
-          <a:p>
-            <a:pPr marL="342900" indent="-342900">
-              <a:spcAft>
-                <a:spcPts val="400"/>
-              </a:spcAft>
-              <a:buSzPct val="100000"/>
-              <a:buChar char="•"/>
-            </a:pPr>
-            <a:r>
-              <a:rPr lang="en-US" sz="1300" dirty="0">
-                <a:solidFill>
-                  <a:schemeClr val="tx2"/>
-                </a:solidFill>
-              </a:rPr>
-              <a:t>Aucune alerte aujourd'hui</a:t>
-            </a:r>
-            <a:endParaRPr lang="en-US" sz="1300" dirty="0"/>
           </a:p>
         </p:txBody>
       </p:sp>
@@ -2457,8 +1715,8 @@
         </p:nvSpPr>
         <p:spPr>
           <a:xfrm>
-            <a:off x="8229600" y="4773168"/>
-            <a:ext cx="457200" cy="228600"/>
+            <a:off x="8229600" y="4754880"/>
+            <a:ext cx="457200" cy="274320"/>
           </a:xfrm>
           <a:prstGeom prst="rect">
             <a:avLst/>
@@ -2470,12 +1728,12 @@
           </a:extLst>
         </p:spPr>
         <p:txBody>
-          <a:bodyPr lIns="0" tIns="0" rIns="0" bIns="0"/>
+          <a:bodyPr/>
           <a:lstStyle>
             <a:lvl1pPr>
-              <a:defRPr sz="1000">
-                <a:solidFill>
-                  <a:schemeClr val="tx2"/>
+              <a:defRPr sz="1100">
+                <a:solidFill>
+                  <a:schemeClr val="tx1"/>
                 </a:solidFill>
               </a:defRPr>
             </a:lvl1pPr>
@@ -2520,13 +1778,13 @@
           <p:cNvPr id="2" name="Text 0"/>
           <p:cNvSpPr/>
           <p:nvPr>
-            <p:ph idx="100" type="body" hasCustomPrompt="1"/>
-          </p:nvPr>
-        </p:nvSpPr>
-        <p:spPr>
-          <a:xfrm>
-            <a:off x="457200" y="365760"/>
-            <a:ext cx="8229600" cy="274320"/>
+            <p:ph idx="100" type="title" hasCustomPrompt="1"/>
+          </p:nvPr>
+        </p:nvSpPr>
+        <p:spPr>
+          <a:xfrm>
+            <a:off x="457200" y="320040"/>
+            <a:ext cx="8229600" cy="731520"/>
           </a:xfrm>
           <a:prstGeom prst="rect">
             <a:avLst/>
@@ -2535,36 +1793,34 @@
           <a:ln/>
         </p:spPr>
         <p:txBody>
-          <a:bodyPr wrap="square" lIns="0" tIns="0" rIns="0" bIns="0" rtlCol="0"/>
+          <a:bodyPr wrap="square" rtlCol="0" anchor="ctr"/>
           <a:lstStyle/>
           <a:p>
             <a:pPr indent="0" marL="0">
               <a:buNone/>
             </a:pPr>
             <a:r>
-              <a:rPr lang="en-US" sz="1200" b="1" spc="300" kern="0" dirty="0">
-                <a:solidFill>
-                  <a:schemeClr val="accent2"/>
+              <a:rPr lang="en-US" sz="3000" b="1" dirty="0">
+                <a:solidFill>
+                  <a:schemeClr val="tx2"/>
                 </a:solidFill>
               </a:rPr>
-              <a:t>LA SOLUTION TECHNOLOGIQUE</a:t>
-            </a:r>
-            <a:endParaRPr lang="en-US" sz="1200" dirty="0"/>
-          </a:p>
-        </p:txBody>
-      </p:sp>
-      <p:sp>
-        <p:nvSpPr>
-          <p:cNvPr id="3" name="Text 0"/>
-          <p:cNvSpPr/>
-          <p:nvPr>
-            <p:ph idx="101" type="title" hasCustomPrompt="1"/>
-          </p:nvPr>
-        </p:nvSpPr>
-        <p:spPr>
-          <a:xfrm>
-            <a:off x="457200" y="685800"/>
-            <a:ext cx="8229600" cy="777240"/>
+              <a:t>Solution envisagée</a:t>
+            </a:r>
+            <a:endParaRPr lang="en-US" sz="3000" dirty="0"/>
+          </a:p>
+        </p:txBody>
+      </p:sp>
+      <p:sp>
+        <p:nvSpPr>
+          <p:cNvPr id="3" name="Text 1"/>
+          <p:cNvSpPr txBox="1"/>
+          <p:nvPr/>
+        </p:nvSpPr>
+        <p:spPr>
+          <a:xfrm>
+            <a:off x="457200" y="1143000"/>
+            <a:ext cx="5440680" cy="3474720"/>
           </a:xfrm>
           <a:prstGeom prst="rect">
             <a:avLst/>
@@ -2573,156 +1829,25 @@
           <a:ln/>
         </p:spPr>
         <p:txBody>
-          <a:bodyPr wrap="square" lIns="0" tIns="0" rIns="0" bIns="0" rtlCol="0" anchor="t"/>
+          <a:bodyPr wrap="square" rtlCol="0" anchor="t"/>
           <a:lstStyle/>
           <a:p>
-            <a:pPr algn="l" indent="0" marL="0">
+            <a:pPr indent="0" marL="0">
+              <a:spcAft>
+                <a:spcPts val="400"/>
+              </a:spcAft>
               <a:buNone/>
             </a:pPr>
             <a:r>
-              <a:rPr lang="en-US" sz="2200" b="1" dirty="0">
+              <a:rPr lang="en-US" sz="1500" b="1" dirty="0">
                 <a:solidFill>
                   <a:schemeClr val="tx1"/>
                 </a:solidFill>
               </a:rPr>
-              <a:t>Un boîtier ESP32 par salle, un serveur qui croise les données</a:t>
-            </a:r>
-            <a:endParaRPr lang="en-US" sz="2200" dirty="0"/>
-          </a:p>
-        </p:txBody>
-      </p:sp>
-      <p:sp>
-        <p:nvSpPr>
-          <p:cNvPr id="4" name="Étape Dans la salle"/>
-          <p:cNvSpPr/>
-          <p:nvPr/>
-        </p:nvSpPr>
-        <p:spPr>
-          <a:xfrm>
-            <a:off x="457200" y="1508760"/>
-            <a:ext cx="2423160" cy="2423160"/>
-          </a:xfrm>
-          <a:prstGeom prst="roundRect">
-            <a:avLst>
-              <a:gd name="adj" fmla="val 3774"/>
-            </a:avLst>
-          </a:prstGeom>
-          <a:solidFill>
-            <a:schemeClr val="bg1"/>
-          </a:solidFill>
-          <a:ln/>
-          <a:effectLst>
-            <a:outerShdw sx="100000" sy="100000" kx="0" ky="0" algn="bl" rotWithShape="0" blurRad="76200" dist="25400" dir="5400000">
-              <a:srgbClr val="13223A">
-                <a:alpha val="12000"/>
-              </a:srgbClr>
-            </a:outerShdw>
-          </a:effectLst>
-        </p:spPr>
-      </p:sp>
-      <p:sp>
-        <p:nvSpPr>
-          <p:cNvPr id="5" name="Cercle Dans la salle"/>
-          <p:cNvSpPr/>
-          <p:nvPr/>
-        </p:nvSpPr>
-        <p:spPr>
-          <a:xfrm>
-            <a:off x="640080" y="1691640"/>
-            <a:ext cx="457200" cy="457200"/>
-          </a:xfrm>
-          <a:prstGeom prst="ellipse">
-            <a:avLst/>
-          </a:prstGeom>
-          <a:solidFill>
-            <a:schemeClr val="tx1"/>
-          </a:solidFill>
-          <a:ln/>
-        </p:spPr>
-      </p:sp>
-      <p:pic>
-        <p:nvPicPr>
-          <p:cNvPr id="6" name="Image 0" descr="Dans la salle">    </p:cNvPr>
-          <p:cNvPicPr>
-            <a:picLocks noChangeAspect="1"/>
-          </p:cNvPicPr>
-          <p:nvPr/>
-        </p:nvPicPr>
-        <p:blipFill>
-          <a:blip r:embed="rId1"/>
-          <a:stretch>
-            <a:fillRect/>
-          </a:stretch>
-        </p:blipFill>
-        <p:spPr>
-          <a:xfrm>
-            <a:off x="754380" y="1805940"/>
-            <a:ext cx="228600" cy="228600"/>
-          </a:xfrm>
-          <a:prstGeom prst="rect">
-            <a:avLst/>
-          </a:prstGeom>
-        </p:spPr>
-      </p:pic>
-      <p:sp>
-        <p:nvSpPr>
-          <p:cNvPr id="7" name="Text 4"/>
-          <p:cNvSpPr txBox="1"/>
-          <p:nvPr/>
-        </p:nvSpPr>
-        <p:spPr>
-          <a:xfrm>
-            <a:off x="1188720" y="1691640"/>
-            <a:ext cx="1554480" cy="457200"/>
-          </a:xfrm>
-          <a:prstGeom prst="rect">
-            <a:avLst/>
-          </a:prstGeom>
-          <a:noFill/>
-          <a:ln/>
-        </p:spPr>
-        <p:txBody>
-          <a:bodyPr wrap="square" lIns="0" tIns="0" rIns="0" bIns="0" rtlCol="0" anchor="ctr"/>
-          <a:lstStyle/>
-          <a:p>
-            <a:pPr indent="0" marL="0">
-              <a:buNone/>
-            </a:pPr>
-            <a:r>
-              <a:rPr lang="en-US" sz="1500" b="1" dirty="0">
-                <a:solidFill>
-                  <a:schemeClr val="tx1"/>
-                </a:solidFill>
-                <a:latin typeface="+mj-lt" pitchFamily="34" charset="0"/>
-                <a:ea typeface="+mj-lt" pitchFamily="34" charset="-122"/>
-                <a:cs typeface="+mj-lt" pitchFamily="34" charset="-120"/>
-              </a:rPr>
-              <a:t>1 · Dans la salle</a:t>
+              <a:t>Un boîtier ESP32 dans chaque salle :</a:t>
             </a:r>
             <a:endParaRPr lang="en-US" sz="1500" dirty="0"/>
           </a:p>
-        </p:txBody>
-      </p:sp>
-      <p:sp>
-        <p:nvSpPr>
-          <p:cNvPr id="8" name="Text 5"/>
-          <p:cNvSpPr txBox="1"/>
-          <p:nvPr/>
-        </p:nvSpPr>
-        <p:spPr>
-          <a:xfrm>
-            <a:off x="640080" y="2286000"/>
-            <a:ext cx="2103120" cy="1554480"/>
-          </a:xfrm>
-          <a:prstGeom prst="rect">
-            <a:avLst/>
-          </a:prstGeom>
-          <a:noFill/>
-          <a:ln/>
-        </p:spPr>
-        <p:txBody>
-          <a:bodyPr wrap="square" lIns="0" tIns="0" rIns="0" bIns="0" rtlCol="0" anchor="t"/>
-          <a:lstStyle/>
           <a:p>
             <a:pPr marL="342900" indent="-342900">
               <a:spcAft>
@@ -2732,14 +1857,14 @@
               <a:buChar char="•"/>
             </a:pPr>
             <a:r>
-              <a:rPr lang="en-US" sz="1200" dirty="0">
-                <a:solidFill>
-                  <a:schemeClr val="tx2"/>
+              <a:rPr lang="en-US" sz="1500" dirty="0">
+                <a:solidFill>
+                  <a:schemeClr val="tx1"/>
                 </a:solidFill>
               </a:rPr>
-              <a:t>QR code dynamique (5 s) + BLE</a:t>
-            </a:r>
-            <a:endParaRPr lang="en-US" sz="1200" dirty="0"/>
+              <a:t>QR code qui change toutes les 5 s + vérification BLE</a:t>
+            </a:r>
+            <a:endParaRPr lang="en-US" sz="1500" dirty="0"/>
           </a:p>
           <a:p>
             <a:pPr marL="342900" indent="-342900">
@@ -2750,14 +1875,14 @@
               <a:buChar char="•"/>
             </a:pPr>
             <a:r>
-              <a:rPr lang="en-US" sz="1200" dirty="0">
-                <a:solidFill>
-                  <a:schemeClr val="tx2"/>
+              <a:rPr lang="en-US" sz="1500" dirty="0">
+                <a:solidFill>
+                  <a:schemeClr val="tx1"/>
                 </a:solidFill>
               </a:rPr>
-              <a:t>Présence : radar mmWave ou PIR</a:t>
-            </a:r>
-            <a:endParaRPr lang="en-US" sz="1200" dirty="0"/>
+              <a:t>Capteur de présence (PIR ou radar) et capteur de CO2</a:t>
+            </a:r>
+            <a:endParaRPr lang="en-US" sz="1500" dirty="0"/>
           </a:p>
           <a:p>
             <a:pPr marL="342900" indent="-342900">
@@ -2768,14 +1893,31 @@
               <a:buChar char="•"/>
             </a:pPr>
             <a:r>
-              <a:rPr lang="en-US" sz="1200" dirty="0">
-                <a:solidFill>
-                  <a:schemeClr val="tx2"/>
+              <a:rPr lang="en-US" sz="1500" dirty="0">
+                <a:solidFill>
+                  <a:schemeClr val="tx1"/>
                 </a:solidFill>
               </a:rPr>
-              <a:t>CO2 et température</a:t>
-            </a:r>
-            <a:endParaRPr lang="en-US" sz="1200" dirty="0"/>
+              <a:t>Compteur d'entrées/sorties à la porte</a:t>
+            </a:r>
+            <a:endParaRPr lang="en-US" sz="1500" dirty="0"/>
+          </a:p>
+          <a:p>
+            <a:pPr indent="0" marL="0">
+              <a:spcAft>
+                <a:spcPts val="400"/>
+              </a:spcAft>
+              <a:buNone/>
+            </a:pPr>
+            <a:r>
+              <a:rPr lang="en-US" sz="1500" b="1" dirty="0">
+                <a:solidFill>
+                  <a:schemeClr val="tx1"/>
+                </a:solidFill>
+              </a:rPr>
+              <a:t>Le serveur compare avec l'emploi du temps :</a:t>
+            </a:r>
+            <a:endParaRPr lang="en-US" sz="1500" dirty="0"/>
           </a:p>
           <a:p>
             <a:pPr marL="342900" indent="-342900">
@@ -2786,169 +1928,15 @@
               <a:buChar char="•"/>
             </a:pPr>
             <a:r>
-              <a:rPr lang="en-US" sz="1200" dirty="0">
-                <a:solidFill>
-                  <a:schemeClr val="tx2"/>
+              <a:rPr lang="en-US" sz="1500" dirty="0">
+                <a:solidFill>
+                  <a:schemeClr val="tx1"/>
                 </a:solidFill>
               </a:rPr>
-              <a:t>Compteur de passage (2 ToF)</a:t>
-            </a:r>
-            <a:endParaRPr lang="en-US" sz="1200" dirty="0"/>
-          </a:p>
-        </p:txBody>
-      </p:sp>
-      <p:sp>
-        <p:nvSpPr>
-          <p:cNvPr id="9" name="Flèche 1"/>
-          <p:cNvSpPr/>
-          <p:nvPr/>
-        </p:nvSpPr>
-        <p:spPr>
-          <a:xfrm>
-            <a:off x="2971800" y="2560320"/>
-            <a:ext cx="297180" cy="320040"/>
-          </a:xfrm>
-          <a:prstGeom prst="rightArrow">
-            <a:avLst/>
-          </a:prstGeom>
-          <a:solidFill>
-            <a:schemeClr val="accent1"/>
-          </a:solidFill>
-          <a:ln/>
-        </p:spPr>
-      </p:sp>
-      <p:sp>
-        <p:nvSpPr>
-          <p:cNvPr id="10" name="Étape Serveur"/>
-          <p:cNvSpPr/>
-          <p:nvPr/>
-        </p:nvSpPr>
-        <p:spPr>
-          <a:xfrm>
-            <a:off x="3360420" y="1508760"/>
-            <a:ext cx="2423160" cy="2423160"/>
-          </a:xfrm>
-          <a:prstGeom prst="roundRect">
-            <a:avLst>
-              <a:gd name="adj" fmla="val 3774"/>
-            </a:avLst>
-          </a:prstGeom>
-          <a:solidFill>
-            <a:schemeClr val="bg1"/>
-          </a:solidFill>
-          <a:ln/>
-          <a:effectLst>
-            <a:outerShdw sx="100000" sy="100000" kx="0" ky="0" algn="bl" rotWithShape="0" blurRad="76200" dist="25400" dir="5400000">
-              <a:srgbClr val="13223A">
-                <a:alpha val="12000"/>
-              </a:srgbClr>
-            </a:outerShdw>
-          </a:effectLst>
-        </p:spPr>
-      </p:sp>
-      <p:sp>
-        <p:nvSpPr>
-          <p:cNvPr id="11" name="Cercle Serveur"/>
-          <p:cNvSpPr/>
-          <p:nvPr/>
-        </p:nvSpPr>
-        <p:spPr>
-          <a:xfrm>
-            <a:off x="3543300" y="1691640"/>
-            <a:ext cx="457200" cy="457200"/>
-          </a:xfrm>
-          <a:prstGeom prst="ellipse">
-            <a:avLst/>
-          </a:prstGeom>
-          <a:solidFill>
-            <a:schemeClr val="tx1"/>
-          </a:solidFill>
-          <a:ln/>
-        </p:spPr>
-      </p:sp>
-      <p:pic>
-        <p:nvPicPr>
-          <p:cNvPr id="12" name="Image 1" descr="Serveur">    </p:cNvPr>
-          <p:cNvPicPr>
-            <a:picLocks noChangeAspect="1"/>
-          </p:cNvPicPr>
-          <p:nvPr/>
-        </p:nvPicPr>
-        <p:blipFill>
-          <a:blip r:embed="rId2"/>
-          <a:stretch>
-            <a:fillRect/>
-          </a:stretch>
-        </p:blipFill>
-        <p:spPr>
-          <a:xfrm>
-            <a:off x="3657600" y="1805940"/>
-            <a:ext cx="228600" cy="228600"/>
-          </a:xfrm>
-          <a:prstGeom prst="rect">
-            <a:avLst/>
-          </a:prstGeom>
-        </p:spPr>
-      </p:pic>
-      <p:sp>
-        <p:nvSpPr>
-          <p:cNvPr id="13" name="Text 9"/>
-          <p:cNvSpPr txBox="1"/>
-          <p:nvPr/>
-        </p:nvSpPr>
-        <p:spPr>
-          <a:xfrm>
-            <a:off x="4091940" y="1691640"/>
-            <a:ext cx="1554480" cy="457200"/>
-          </a:xfrm>
-          <a:prstGeom prst="rect">
-            <a:avLst/>
-          </a:prstGeom>
-          <a:noFill/>
-          <a:ln/>
-        </p:spPr>
-        <p:txBody>
-          <a:bodyPr wrap="square" lIns="0" tIns="0" rIns="0" bIns="0" rtlCol="0" anchor="ctr"/>
-          <a:lstStyle/>
-          <a:p>
-            <a:pPr indent="0" marL="0">
-              <a:buNone/>
-            </a:pPr>
-            <a:r>
-              <a:rPr lang="en-US" sz="1500" b="1" dirty="0">
-                <a:solidFill>
-                  <a:schemeClr val="tx1"/>
-                </a:solidFill>
-                <a:latin typeface="+mj-lt" pitchFamily="34" charset="0"/>
-                <a:ea typeface="+mj-lt" pitchFamily="34" charset="-122"/>
-                <a:cs typeface="+mj-lt" pitchFamily="34" charset="-120"/>
-              </a:rPr>
-              <a:t>2 · Serveur</a:t>
+              <a:t>quelqu'un dans la salle hors créneau</a:t>
             </a:r>
             <a:endParaRPr lang="en-US" sz="1500" dirty="0"/>
           </a:p>
-        </p:txBody>
-      </p:sp>
-      <p:sp>
-        <p:nvSpPr>
-          <p:cNvPr id="14" name="Text 10"/>
-          <p:cNvSpPr txBox="1"/>
-          <p:nvPr/>
-        </p:nvSpPr>
-        <p:spPr>
-          <a:xfrm>
-            <a:off x="3543300" y="2286000"/>
-            <a:ext cx="2103120" cy="1554480"/>
-          </a:xfrm>
-          <a:prstGeom prst="rect">
-            <a:avLst/>
-          </a:prstGeom>
-          <a:noFill/>
-          <a:ln/>
-        </p:spPr>
-        <p:txBody>
-          <a:bodyPr wrap="square" lIns="0" tIns="0" rIns="0" bIns="0" rtlCol="0" anchor="t"/>
-          <a:lstStyle/>
           <a:p>
             <a:pPr marL="342900" indent="-342900">
               <a:spcAft>
@@ -2958,14 +1946,14 @@
               <a:buChar char="•"/>
             </a:pPr>
             <a:r>
-              <a:rPr lang="en-US" sz="1200" dirty="0">
-                <a:solidFill>
-                  <a:schemeClr val="tx2"/>
+              <a:rPr lang="en-US" sz="1500" dirty="0">
+                <a:solidFill>
+                  <a:schemeClr val="tx1"/>
                 </a:solidFill>
               </a:rPr>
-              <a:t>Données reçues en MQTT (Wi-Fi)</a:t>
-            </a:r>
-            <a:endParaRPr lang="en-US" sz="1200" dirty="0"/>
+              <a:t>plus de personnes comptées que d'émargés</a:t>
+            </a:r>
+            <a:endParaRPr lang="en-US" sz="1500" dirty="0"/>
           </a:p>
           <a:p>
             <a:pPr marL="342900" indent="-342900">
@@ -2976,138 +1964,137 @@
               <a:buChar char="•"/>
             </a:pPr>
             <a:r>
-              <a:rPr lang="en-US" sz="1200" dirty="0">
-                <a:solidFill>
-                  <a:schemeClr val="tx2"/>
+              <a:rPr lang="en-US" sz="1500" dirty="0">
+                <a:solidFill>
+                  <a:schemeClr val="tx1"/>
                 </a:solidFill>
               </a:rPr>
-              <a:t>Croise émargement, comptage et emploi du temps</a:t>
-            </a:r>
-            <a:endParaRPr lang="en-US" sz="1200" dirty="0"/>
-          </a:p>
-          <a:p>
-            <a:pPr marL="342900" indent="-342900">
-              <a:spcAft>
-                <a:spcPts val="400"/>
-              </a:spcAft>
-              <a:buSzPct val="100000"/>
-              <a:buChar char="•"/>
-            </a:pPr>
-            <a:r>
-              <a:rPr lang="en-US" sz="1200" dirty="0">
-                <a:solidFill>
-                  <a:schemeClr val="tx2"/>
-                </a:solidFill>
-              </a:rPr>
-              <a:t>Tableau de bord : salles, présents, qualité de l'air</a:t>
-            </a:r>
-            <a:endParaRPr lang="en-US" sz="1200" dirty="0"/>
-          </a:p>
-        </p:txBody>
-      </p:sp>
-      <p:sp>
-        <p:nvSpPr>
-          <p:cNvPr id="15" name="Flèche 2"/>
+              <a:t>scan par un étudiant qui n'est pas du groupe</a:t>
+            </a:r>
+            <a:endParaRPr lang="en-US" sz="1500" dirty="0"/>
+          </a:p>
+        </p:txBody>
+      </p:sp>
+      <p:sp>
+        <p:nvSpPr>
+          <p:cNvPr id="4" name="Boîtier ESP32 (salle)"/>
           <p:cNvSpPr/>
           <p:nvPr/>
         </p:nvSpPr>
         <p:spPr>
           <a:xfrm>
-            <a:off x="5875020" y="2560320"/>
-            <a:ext cx="297180" cy="320040"/>
-          </a:xfrm>
-          <a:prstGeom prst="rightArrow">
+            <a:off x="6035040" y="1280160"/>
+            <a:ext cx="2560320" cy="548640"/>
+          </a:xfrm>
+          <a:prstGeom prst="rect">
             <a:avLst/>
           </a:prstGeom>
           <a:solidFill>
-            <a:schemeClr val="accent1"/>
+            <a:schemeClr val="bg2"/>
           </a:solidFill>
+          <a:ln w="12700">
+            <a:solidFill>
+              <a:schemeClr val="tx2"/>
+            </a:solidFill>
+            <a:prstDash val="solid"/>
+          </a:ln>
+        </p:spPr>
+      </p:sp>
+      <p:sp>
+        <p:nvSpPr>
+          <p:cNvPr id="5" name="Text 3"/>
+          <p:cNvSpPr txBox="1"/>
+          <p:nvPr/>
+        </p:nvSpPr>
+        <p:spPr>
+          <a:xfrm>
+            <a:off x="6035040" y="1280160"/>
+            <a:ext cx="2560320" cy="548640"/>
+          </a:xfrm>
+          <a:prstGeom prst="rect">
+            <a:avLst/>
+          </a:prstGeom>
+          <a:noFill/>
           <a:ln/>
         </p:spPr>
-      </p:sp>
-      <p:sp>
-        <p:nvSpPr>
-          <p:cNvPr id="16" name="Étape Alertes intrusion"/>
+        <p:txBody>
+          <a:bodyPr wrap="square" rtlCol="0" anchor="ctr"/>
+          <a:lstStyle/>
+          <a:p>
+            <a:pPr algn="ctr" indent="0" marL="0">
+              <a:buNone/>
+            </a:pPr>
+            <a:r>
+              <a:rPr lang="en-US" sz="1400" dirty="0">
+                <a:solidFill>
+                  <a:schemeClr val="tx1"/>
+                </a:solidFill>
+              </a:rPr>
+              <a:t>Boîtier ESP32 (salle)</a:t>
+            </a:r>
+            <a:endParaRPr lang="en-US" sz="1400" dirty="0"/>
+          </a:p>
+        </p:txBody>
+      </p:sp>
+      <p:sp>
+        <p:nvSpPr>
+          <p:cNvPr id="6" name="Flèche"/>
           <p:cNvSpPr/>
           <p:nvPr/>
         </p:nvSpPr>
         <p:spPr>
           <a:xfrm>
-            <a:off x="6263640" y="1508760"/>
-            <a:ext cx="2423160" cy="2423160"/>
-          </a:xfrm>
-          <a:prstGeom prst="roundRect">
-            <a:avLst>
-              <a:gd name="adj" fmla="val 3774"/>
-            </a:avLst>
-          </a:prstGeom>
-          <a:solidFill>
-            <a:schemeClr val="tx1"/>
-          </a:solidFill>
-          <a:ln/>
-          <a:effectLst>
-            <a:outerShdw sx="100000" sy="100000" kx="0" ky="0" algn="bl" rotWithShape="0" blurRad="76200" dist="25400" dir="5400000">
-              <a:srgbClr val="13223A">
-                <a:alpha val="12000"/>
-              </a:srgbClr>
-            </a:outerShdw>
-          </a:effectLst>
-        </p:spPr>
-      </p:sp>
-      <p:sp>
-        <p:nvSpPr>
-          <p:cNvPr id="17" name="Cercle Alertes intrusion"/>
+            <a:off x="7315200" y="1828800"/>
+            <a:ext cx="0" cy="365760"/>
+          </a:xfrm>
+          <a:prstGeom prst="line">
+            <a:avLst/>
+          </a:prstGeom>
+          <a:noFill/>
+          <a:ln w="19050">
+            <a:solidFill>
+              <a:schemeClr val="tx2"/>
+            </a:solidFill>
+            <a:prstDash val="solid"/>
+            <a:tailEnd type="triangle"/>
+          </a:ln>
+        </p:spPr>
+      </p:sp>
+      <p:sp>
+        <p:nvSpPr>
+          <p:cNvPr id="7" name="Serveur (MQTT, Wi-Fi)"/>
           <p:cNvSpPr/>
           <p:nvPr/>
         </p:nvSpPr>
         <p:spPr>
           <a:xfrm>
-            <a:off x="6446520" y="1691640"/>
-            <a:ext cx="457200" cy="457200"/>
-          </a:xfrm>
-          <a:prstGeom prst="ellipse">
+            <a:off x="6035040" y="2194560"/>
+            <a:ext cx="2560320" cy="548640"/>
+          </a:xfrm>
+          <a:prstGeom prst="rect">
             <a:avLst/>
           </a:prstGeom>
           <a:solidFill>
-            <a:schemeClr val="accent1"/>
+            <a:schemeClr val="bg2"/>
           </a:solidFill>
-          <a:ln/>
-        </p:spPr>
-      </p:sp>
-      <p:pic>
-        <p:nvPicPr>
-          <p:cNvPr id="18" name="Image 2" descr="Alertes intrusion">    </p:cNvPr>
-          <p:cNvPicPr>
-            <a:picLocks noChangeAspect="1"/>
-          </p:cNvPicPr>
-          <p:nvPr/>
-        </p:nvPicPr>
-        <p:blipFill>
-          <a:blip r:embed="rId3"/>
-          <a:stretch>
-            <a:fillRect/>
-          </a:stretch>
-        </p:blipFill>
-        <p:spPr>
-          <a:xfrm>
-            <a:off x="6560820" y="1805940"/>
-            <a:ext cx="228600" cy="228600"/>
-          </a:xfrm>
-          <a:prstGeom prst="rect">
-            <a:avLst/>
-          </a:prstGeom>
-        </p:spPr>
-      </p:pic>
-      <p:sp>
-        <p:nvSpPr>
-          <p:cNvPr id="19" name="Text 14"/>
+          <a:ln w="12700">
+            <a:solidFill>
+              <a:schemeClr val="tx2"/>
+            </a:solidFill>
+            <a:prstDash val="solid"/>
+          </a:ln>
+        </p:spPr>
+      </p:sp>
+      <p:sp>
+        <p:nvSpPr>
+          <p:cNvPr id="8" name="Text 6"/>
           <p:cNvSpPr txBox="1"/>
           <p:nvPr/>
         </p:nvSpPr>
         <p:spPr>
           <a:xfrm>
-            <a:off x="6995160" y="1691640"/>
-            <a:ext cx="1554480" cy="457200"/>
+            <a:off x="6035040" y="2194560"/>
+            <a:ext cx="2560320" cy="548640"/>
           </a:xfrm>
           <a:prstGeom prst="rect">
             <a:avLst/>
@@ -3116,37 +2103,83 @@
           <a:ln/>
         </p:spPr>
         <p:txBody>
-          <a:bodyPr wrap="square" lIns="0" tIns="0" rIns="0" bIns="0" rtlCol="0" anchor="ctr"/>
+          <a:bodyPr wrap="square" rtlCol="0" anchor="ctr"/>
           <a:lstStyle/>
           <a:p>
-            <a:pPr indent="0" marL="0">
+            <a:pPr algn="ctr" indent="0" marL="0">
               <a:buNone/>
             </a:pPr>
             <a:r>
-              <a:rPr lang="en-US" sz="1500" b="1" dirty="0">
-                <a:solidFill>
-                  <a:schemeClr val="accent1"/>
-                </a:solidFill>
-                <a:latin typeface="+mj-lt" pitchFamily="34" charset="0"/>
-                <a:ea typeface="+mj-lt" pitchFamily="34" charset="-122"/>
-                <a:cs typeface="+mj-lt" pitchFamily="34" charset="-120"/>
+              <a:rPr lang="en-US" sz="1400" dirty="0">
+                <a:solidFill>
+                  <a:schemeClr val="tx1"/>
+                </a:solidFill>
               </a:rPr>
-              <a:t>3 · Alertes intrusion</a:t>
-            </a:r>
-            <a:endParaRPr lang="en-US" sz="1500" dirty="0"/>
-          </a:p>
-        </p:txBody>
-      </p:sp>
-      <p:sp>
-        <p:nvSpPr>
-          <p:cNvPr id="20" name="Text 15"/>
+              <a:t>Serveur (MQTT, Wi-Fi)</a:t>
+            </a:r>
+            <a:endParaRPr lang="en-US" sz="1400" dirty="0"/>
+          </a:p>
+        </p:txBody>
+      </p:sp>
+      <p:sp>
+        <p:nvSpPr>
+          <p:cNvPr id="9" name="Flèche"/>
+          <p:cNvSpPr/>
+          <p:nvPr/>
+        </p:nvSpPr>
+        <p:spPr>
+          <a:xfrm>
+            <a:off x="7315200" y="2743200"/>
+            <a:ext cx="0" cy="365760"/>
+          </a:xfrm>
+          <a:prstGeom prst="line">
+            <a:avLst/>
+          </a:prstGeom>
+          <a:noFill/>
+          <a:ln w="19050">
+            <a:solidFill>
+              <a:schemeClr val="tx2"/>
+            </a:solidFill>
+            <a:prstDash val="solid"/>
+            <a:tailEnd type="triangle"/>
+          </a:ln>
+        </p:spPr>
+      </p:sp>
+      <p:sp>
+        <p:nvSpPr>
+          <p:cNvPr id="10" name="Tableau de bord + alertes"/>
+          <p:cNvSpPr/>
+          <p:nvPr/>
+        </p:nvSpPr>
+        <p:spPr>
+          <a:xfrm>
+            <a:off x="6035040" y="3108960"/>
+            <a:ext cx="2560320" cy="548640"/>
+          </a:xfrm>
+          <a:prstGeom prst="rect">
+            <a:avLst/>
+          </a:prstGeom>
+          <a:solidFill>
+            <a:schemeClr val="bg2"/>
+          </a:solidFill>
+          <a:ln w="12700">
+            <a:solidFill>
+              <a:schemeClr val="tx2"/>
+            </a:solidFill>
+            <a:prstDash val="solid"/>
+          </a:ln>
+        </p:spPr>
+      </p:sp>
+      <p:sp>
+        <p:nvSpPr>
+          <p:cNvPr id="11" name="Text 9"/>
           <p:cNvSpPr txBox="1"/>
           <p:nvPr/>
         </p:nvSpPr>
         <p:spPr>
           <a:xfrm>
-            <a:off x="6446520" y="2286000"/>
-            <a:ext cx="2103120" cy="1554480"/>
+            <a:off x="6035040" y="3108960"/>
+            <a:ext cx="2560320" cy="548640"/>
           </a:xfrm>
           <a:prstGeom prst="rect">
             <a:avLst/>
@@ -3155,127 +2188,34 @@
           <a:ln/>
         </p:spPr>
         <p:txBody>
-          <a:bodyPr wrap="square" lIns="0" tIns="0" rIns="0" bIns="0" rtlCol="0" anchor="t"/>
+          <a:bodyPr wrap="square" rtlCol="0" anchor="ctr"/>
           <a:lstStyle/>
           <a:p>
-            <a:pPr marL="342900" indent="-342900">
-              <a:spcAft>
-                <a:spcPts val="400"/>
-              </a:spcAft>
-              <a:buSzPct val="100000"/>
-              <a:buChar char="•"/>
-            </a:pPr>
-            <a:r>
-              <a:rPr lang="en-US" sz="1200" dirty="0">
-                <a:solidFill>
-                  <a:schemeClr val="accent4"/>
+            <a:pPr algn="ctr" indent="0" marL="0">
+              <a:buNone/>
+            </a:pPr>
+            <a:r>
+              <a:rPr lang="en-US" sz="1400" dirty="0">
+                <a:solidFill>
+                  <a:schemeClr val="tx1"/>
                 </a:solidFill>
               </a:rPr>
-              <a:t>Présence détectée hors créneau</a:t>
-            </a:r>
-            <a:endParaRPr lang="en-US" sz="1200" dirty="0"/>
-          </a:p>
-          <a:p>
-            <a:pPr marL="342900" indent="-342900">
-              <a:spcAft>
-                <a:spcPts val="400"/>
-              </a:spcAft>
-              <a:buSzPct val="100000"/>
-              <a:buChar char="•"/>
-            </a:pPr>
-            <a:r>
-              <a:rPr lang="en-US" sz="1200" dirty="0">
-                <a:solidFill>
-                  <a:schemeClr val="accent4"/>
-                </a:solidFill>
-              </a:rPr>
-              <a:t>25 comptés, 22 émargés : 3 non identifiés</a:t>
-            </a:r>
-            <a:endParaRPr lang="en-US" sz="1200" dirty="0"/>
-          </a:p>
-          <a:p>
-            <a:pPr marL="342900" indent="-342900">
-              <a:spcAft>
-                <a:spcPts val="400"/>
-              </a:spcAft>
-              <a:buSzPct val="100000"/>
-              <a:buChar char="•"/>
-            </a:pPr>
-            <a:r>
-              <a:rPr lang="en-US" sz="1200" dirty="0">
-                <a:solidFill>
-                  <a:schemeClr val="accent4"/>
-                </a:solidFill>
-              </a:rPr>
-              <a:t>Scan hors du groupe : refusé et signalé</a:t>
-            </a:r>
-            <a:endParaRPr lang="en-US" sz="1200" dirty="0"/>
-          </a:p>
-        </p:txBody>
-      </p:sp>
-      <p:sp>
-        <p:nvSpPr>
-          <p:cNvPr id="21" name="Encadré RGPD"/>
-          <p:cNvSpPr/>
-          <p:nvPr/>
-        </p:nvSpPr>
-        <p:spPr>
-          <a:xfrm>
-            <a:off x="457200" y="4096512"/>
-            <a:ext cx="8229600" cy="530352"/>
-          </a:xfrm>
-          <a:prstGeom prst="roundRect">
-            <a:avLst>
-              <a:gd name="adj" fmla="val 13793"/>
-            </a:avLst>
-          </a:prstGeom>
-          <a:solidFill>
-            <a:schemeClr val="bg1"/>
-          </a:solidFill>
-          <a:ln/>
-          <a:effectLst>
-            <a:outerShdw sx="100000" sy="100000" kx="0" ky="0" algn="bl" rotWithShape="0" blurRad="76200" dist="25400" dir="5400000">
-              <a:srgbClr val="13223A">
-                <a:alpha val="12000"/>
-              </a:srgbClr>
-            </a:outerShdw>
-          </a:effectLst>
-        </p:spPr>
-      </p:sp>
-      <p:pic>
-        <p:nvPicPr>
-          <p:cNvPr id="22" name="Image 3" descr="Cadenas">    </p:cNvPr>
-          <p:cNvPicPr>
-            <a:picLocks noChangeAspect="1"/>
-          </p:cNvPicPr>
-          <p:nvPr/>
-        </p:nvPicPr>
-        <p:blipFill>
-          <a:blip r:embed="rId4"/>
-          <a:stretch>
-            <a:fillRect/>
-          </a:stretch>
-        </p:blipFill>
-        <p:spPr>
-          <a:xfrm>
-            <a:off x="658368" y="4224528"/>
-            <a:ext cx="274320" cy="274320"/>
-          </a:xfrm>
-          <a:prstGeom prst="rect">
-            <a:avLst/>
-          </a:prstGeom>
-        </p:spPr>
-      </p:pic>
-      <p:sp>
-        <p:nvSpPr>
-          <p:cNvPr id="23" name="Text 17"/>
+              <a:t>Tableau de bord + alertes</a:t>
+            </a:r>
+            <a:endParaRPr lang="en-US" sz="1400" dirty="0"/>
+          </a:p>
+        </p:txBody>
+      </p:sp>
+      <p:sp>
+        <p:nvSpPr>
+          <p:cNvPr id="12" name="Text 10"/>
           <p:cNvSpPr txBox="1"/>
           <p:nvPr/>
         </p:nvSpPr>
         <p:spPr>
           <a:xfrm>
-            <a:off x="1097280" y="4096512"/>
-            <a:ext cx="7406640" cy="530352"/>
+            <a:off x="6035040" y="3794760"/>
+            <a:ext cx="2560320" cy="731520"/>
           </a:xfrm>
           <a:prstGeom prst="rect">
             <a:avLst/>
@@ -3284,30 +2224,19 @@
           <a:ln/>
         </p:spPr>
         <p:txBody>
-          <a:bodyPr wrap="square" lIns="0" tIns="0" rIns="0" bIns="0" rtlCol="0" anchor="ctr"/>
+          <a:bodyPr wrap="square" rtlCol="0" anchor="t"/>
           <a:lstStyle/>
           <a:p>
-            <a:pPr indent="0" marL="0">
+            <a:pPr algn="ctr" indent="0" marL="0">
               <a:buNone/>
             </a:pPr>
             <a:r>
-              <a:rPr lang="en-US" sz="1300" b="1" dirty="0">
+              <a:rPr lang="en-US" sz="1300" i="1" dirty="0">
                 <a:solidFill>
                   <a:schemeClr val="tx1"/>
                 </a:solidFill>
               </a:rPr>
-              <a:t>Sans caméra : </a:t>
-            </a:r>
-            <a:pPr indent="0" marL="0">
-              <a:buNone/>
-            </a:pPr>
-            <a:r>
-              <a:rPr lang="en-US" sz="1300" dirty="0">
-                <a:solidFill>
-                  <a:schemeClr val="tx2"/>
-                </a:solidFill>
-              </a:rPr>
-              <a:t>le système sait qu'il y a un intrus et combien, pas qui. Pas de surveillance vidéo, compatible RGPD.</a:t>
+              <a:t>Sans caméra : on sait combien de personnes sont en trop, pas qui (RGPD)</a:t>
             </a:r>
             <a:endParaRPr lang="en-US" sz="1300" dirty="0"/>
           </a:p>
@@ -3325,8 +2254,8 @@
         </p:nvSpPr>
         <p:spPr>
           <a:xfrm>
-            <a:off x="8229600" y="4773168"/>
-            <a:ext cx="457200" cy="228600"/>
+            <a:off x="8229600" y="4754880"/>
+            <a:ext cx="457200" cy="274320"/>
           </a:xfrm>
           <a:prstGeom prst="rect">
             <a:avLst/>
@@ -3338,12 +2267,12 @@
           </a:extLst>
         </p:spPr>
         <p:txBody>
-          <a:bodyPr lIns="0" tIns="0" rIns="0" bIns="0"/>
+          <a:bodyPr/>
           <a:lstStyle>
             <a:lvl1pPr>
-              <a:defRPr sz="1000">
-                <a:solidFill>
-                  <a:schemeClr val="tx2"/>
+              <a:defRPr sz="1100">
+                <a:solidFill>
+                  <a:schemeClr val="tx1"/>
                 </a:solidFill>
               </a:defRPr>
             </a:lvl1pPr>
@@ -3367,47 +2296,47 @@
 </file>
 
 <file path=ppt/theme/theme1.xml><?xml version="1.0" encoding="utf-8"?>
-<a:theme xmlns:a="http://schemas.openxmlformats.org/drawingml/2006/main" name="Boitier de salle">
+<a:theme xmlns:a="http://schemas.openxmlformats.org/drawingml/2006/main" name="Simple">
   <a:themeElements>
-    <a:clrScheme name="Boitier de salle">
+    <a:clrScheme name="Simple">
       <a:dk1>
-        <a:srgbClr val="13223A"/>
+        <a:srgbClr val="222222"/>
       </a:dk1>
       <a:lt1>
         <a:srgbClr val="FFFFFF"/>
       </a:lt1>
       <a:dk2>
-        <a:srgbClr val="3E4A5C"/>
+        <a:srgbClr val="1F3864"/>
       </a:dk2>
       <a:lt2>
-        <a:srgbClr val="EEF1F5"/>
+        <a:srgbClr val="F2F2F2"/>
       </a:lt2>
       <a:accent1>
-        <a:srgbClr val="E8863A"/>
+        <a:srgbClr val="1F3864"/>
       </a:accent1>
       <a:accent2>
-        <a:srgbClr val="B4561B"/>
+        <a:srgbClr val="4472C4"/>
       </a:accent2>
       <a:accent3>
-        <a:srgbClr val="2F6FA7"/>
+        <a:srgbClr val="A5A5A5"/>
       </a:accent3>
       <a:accent4>
-        <a:srgbClr val="C9D3E0"/>
+        <a:srgbClr val="ED7D31"/>
       </a:accent4>
       <a:accent5>
-        <a:srgbClr val="5B8C5A"/>
+        <a:srgbClr val="70AD47"/>
       </a:accent5>
       <a:accent6>
-        <a:srgbClr val="8A5A9E"/>
+        <a:srgbClr val="5B9BD5"/>
       </a:accent6>
       <a:hlink>
-        <a:srgbClr val="2F6FA7"/>
+        <a:srgbClr val="0563C1"/>
       </a:hlink>
       <a:folHlink>
-        <a:srgbClr val="8A5A9E"/>
+        <a:srgbClr val="954F72"/>
       </a:folHlink>
     </a:clrScheme>
-    <a:fontScheme name="Boitier de salle">
+    <a:fontScheme name="Simple">
       <a:majorFont>
         <a:latin typeface="Arial"/>
         <a:ea typeface=""/>

</xml_diff>

<commit_message>
Émargement par carte étudiante (NFC) à la place du QR code
Co-Authored-By: Claude Opus 5.5 <noreply@anthropic.com>
Claude-Session: https://claude.ai/code/session_01VGmcgWjrz92j7VmNBH7VUY
</commit_message>
<xml_diff>
--- a/sae_iut2030/SAE_IUT2030_boitier_salle.pptx
+++ b/sae_iut2030/SAE_IUT2030_boitier_salle.pptx
@@ -109,17 +109,17 @@
   <p:extLst>
     <p:ext uri="{521415D9-36F7-43E2-AB2F-B90AF26B5E84}">
       <p14:sectionLst xmlns:p14="http://schemas.microsoft.com/office/powerpoint/2010/main">
-        <p14:section name="Titre" id="{1810b617-c6fb-32bc-d090-fd60214793a8}">
+        <p14:section name="Titre" id="{6cf42937-3aaa-e3d2-9071-a7a81e365c4f}">
           <p14:sldIdLst>
             <p14:sldId id="256"/>
           </p14:sldIdLst>
         </p14:section>
-        <p14:section name="Problématique" id="{0181fd16-9585-84d8-4d1b-52d7ba89369d}">
+        <p14:section name="Problématique" id="{3a379ead-19c2-0b15-5cdd-b42299472c67}">
           <p14:sldIdLst>
             <p14:sldId id="257"/>
           </p14:sldIdLst>
         </p14:section>
-        <p14:section name="Solution" id="{b80f3828-1833-97b5-527a-c559fff56600}">
+        <p14:section name="Solution" id="{a5d3719d-a484-d749-706b-10d8dd9db685}">
           <p14:sldIdLst>
             <p14:sldId id="258"/>
           </p14:sldIdLst>
@@ -704,7 +704,7 @@
           <a:p>
             <a:r>
               <a:rPr lang="en-US" dirty="0"/>
-              <a:t>Le cœur du projet est l'émargement ; l'occupation et l'intrusion sont des extensions avec le même boîtier. Les données se vérifient entre elles : 20 émargés mais salle vide = anomalie. Seul matériel en plus pour l'intrusion : le compteur à la porte. Démo prévue : une salle équipée avec un intrus simulé.</a:t>
+              <a:t>Le cœur du projet est l'émargement par carte étudiante (lecteur NFC RC522 sur l'ESP32) ; aucune caméra, ni dans la salle ni sur les téléphones. Si quelqu'un badge pour un absent, le compteur de la porte voit qu'il y a moins de personnes que de badges. L'occupation et l'intrusion sont des extensions avec le même boîtier. Les données se vérifient entre elles : 20 émargés mais salle vide = anomalie. Seul matériel en plus pour l'intrusion : le compteur à la porte. Démo prévue : une salle équipée avec un intrus simulé.</a:t>
             </a:r>
             <a:endParaRPr lang="en-US" dirty="0"/>
           </a:p>
@@ -1862,7 +1862,7 @@
                   <a:schemeClr val="tx1"/>
                 </a:solidFill>
               </a:rPr>
-              <a:t>QR code qui change toutes les 5 s + vérification BLE</a:t>
+              <a:t>Lecteur NFC : l'étudiant badge avec sa carte étudiante</a:t>
             </a:r>
             <a:endParaRPr lang="en-US" sz="1500" dirty="0"/>
           </a:p>
@@ -1969,7 +1969,7 @@
                   <a:schemeClr val="tx1"/>
                 </a:solidFill>
               </a:rPr>
-              <a:t>scan par un étudiant qui n'est pas du groupe</a:t>
+              <a:t>carte d'un étudiant qui n'est pas du groupe</a:t>
             </a:r>
             <a:endParaRPr lang="en-US" sz="1500" dirty="0"/>
           </a:p>

</xml_diff>